<commit_message>
After submit thesis 2025-09-05
Final version of everything.

ch4 use files with final_...
ch5 use files in the data final final supreme or something
</commit_message>
<xml_diff>
--- a/ThesisChapter3Plots/20230522-PhDmeeting.pptx
+++ b/ThesisChapter3Plots/20230522-PhDmeeting.pptx
@@ -21,9 +21,10 @@
     <p:sldId id="271" r:id="rId15"/>
     <p:sldId id="272" r:id="rId16"/>
     <p:sldId id="274" r:id="rId17"/>
-    <p:sldId id="276" r:id="rId18"/>
-    <p:sldId id="275" r:id="rId19"/>
-    <p:sldId id="273" r:id="rId20"/>
+    <p:sldId id="277" r:id="rId18"/>
+    <p:sldId id="276" r:id="rId19"/>
+    <p:sldId id="275" r:id="rId20"/>
+    <p:sldId id="273" r:id="rId21"/>
   </p:sldIdLst>
   <p:sldSz cx="12192000" cy="6858000"/>
   <p:notesSz cx="6858000" cy="9144000"/>
@@ -133,13 +134,180 @@
 <file path=ppt/revisionInfo.xml><?xml version="1.0" encoding="utf-8"?>
 <p1510:revInfo xmlns:a="http://schemas.openxmlformats.org/drawingml/2006/main" xmlns:r="http://schemas.openxmlformats.org/officeDocument/2006/relationships" xmlns:p1510="http://schemas.microsoft.com/office/powerpoint/2015/10/main">
   <p1510:revLst>
-    <p1510:client id="{2F9C920F-B837-426B-B15A-4F4274BFBB22}" v="580" dt="2023-05-23T11:08:25.732"/>
+    <p1510:client id="{F052111D-B225-4361-BF20-F8DD3212B204}" v="14" dt="2025-08-27T11:13:16.451"/>
   </p1510:revLst>
 </p1510:revInfo>
 </file>
 
 <file path=ppt/changesInfos/changesInfo1.xml><?xml version="1.0" encoding="utf-8"?>
 <pc:chgInfo xmlns:a="http://schemas.openxmlformats.org/drawingml/2006/main" xmlns:r="http://schemas.openxmlformats.org/officeDocument/2006/relationships" xmlns:ac="http://schemas.microsoft.com/office/drawing/2013/main/command" xmlns:pc="http://schemas.microsoft.com/office/powerpoint/2013/main/command">
+  <pc:docChgLst>
+    <pc:chgData name="KONGKAEW, PUTTIWAT" userId="a8adac1e-848f-4d84-b961-6a7ffb648b49" providerId="ADAL" clId="{F052111D-B225-4361-BF20-F8DD3212B204}"/>
+    <pc:docChg chg="undo custSel addSld modSld">
+      <pc:chgData name="KONGKAEW, PUTTIWAT" userId="a8adac1e-848f-4d84-b961-6a7ffb648b49" providerId="ADAL" clId="{F052111D-B225-4361-BF20-F8DD3212B204}" dt="2025-08-27T11:13:58.428" v="295" actId="1035"/>
+      <pc:docMkLst>
+        <pc:docMk/>
+      </pc:docMkLst>
+      <pc:sldChg chg="addSp modSp mod">
+        <pc:chgData name="KONGKAEW, PUTTIWAT" userId="a8adac1e-848f-4d84-b961-6a7ffb648b49" providerId="ADAL" clId="{F052111D-B225-4361-BF20-F8DD3212B204}" dt="2025-08-27T11:09:19.329" v="146" actId="14100"/>
+        <pc:sldMkLst>
+          <pc:docMk/>
+          <pc:sldMk cId="2224687866" sldId="268"/>
+        </pc:sldMkLst>
+        <pc:spChg chg="add mod">
+          <ac:chgData name="KONGKAEW, PUTTIWAT" userId="a8adac1e-848f-4d84-b961-6a7ffb648b49" providerId="ADAL" clId="{F052111D-B225-4361-BF20-F8DD3212B204}" dt="2025-08-27T11:08:43.848" v="144" actId="164"/>
+          <ac:spMkLst>
+            <pc:docMk/>
+            <pc:sldMk cId="2224687866" sldId="268"/>
+            <ac:spMk id="3" creationId="{EF516597-E7C5-9821-7DA5-E9ACEEFBD80B}"/>
+          </ac:spMkLst>
+        </pc:spChg>
+        <pc:spChg chg="add mod">
+          <ac:chgData name="KONGKAEW, PUTTIWAT" userId="a8adac1e-848f-4d84-b961-6a7ffb648b49" providerId="ADAL" clId="{F052111D-B225-4361-BF20-F8DD3212B204}" dt="2025-08-27T11:08:43.848" v="144" actId="164"/>
+          <ac:spMkLst>
+            <pc:docMk/>
+            <pc:sldMk cId="2224687866" sldId="268"/>
+            <ac:spMk id="4" creationId="{19E2AEDD-2081-284A-D213-07D2E1AC2EC1}"/>
+          </ac:spMkLst>
+        </pc:spChg>
+        <pc:spChg chg="add mod">
+          <ac:chgData name="KONGKAEW, PUTTIWAT" userId="a8adac1e-848f-4d84-b961-6a7ffb648b49" providerId="ADAL" clId="{F052111D-B225-4361-BF20-F8DD3212B204}" dt="2025-08-27T11:08:43.848" v="144" actId="164"/>
+          <ac:spMkLst>
+            <pc:docMk/>
+            <pc:sldMk cId="2224687866" sldId="268"/>
+            <ac:spMk id="5" creationId="{C70E6F2C-B582-2222-A0FC-E1CB131E8AC4}"/>
+          </ac:spMkLst>
+        </pc:spChg>
+        <pc:spChg chg="add mod">
+          <ac:chgData name="KONGKAEW, PUTTIWAT" userId="a8adac1e-848f-4d84-b961-6a7ffb648b49" providerId="ADAL" clId="{F052111D-B225-4361-BF20-F8DD3212B204}" dt="2025-08-27T11:08:43.848" v="144" actId="164"/>
+          <ac:spMkLst>
+            <pc:docMk/>
+            <pc:sldMk cId="2224687866" sldId="268"/>
+            <ac:spMk id="6" creationId="{AA096EC2-9AB0-71E8-D6B0-0040112B1067}"/>
+          </ac:spMkLst>
+        </pc:spChg>
+        <pc:spChg chg="add mod">
+          <ac:chgData name="KONGKAEW, PUTTIWAT" userId="a8adac1e-848f-4d84-b961-6a7ffb648b49" providerId="ADAL" clId="{F052111D-B225-4361-BF20-F8DD3212B204}" dt="2025-08-27T11:08:43.848" v="144" actId="164"/>
+          <ac:spMkLst>
+            <pc:docMk/>
+            <pc:sldMk cId="2224687866" sldId="268"/>
+            <ac:spMk id="7" creationId="{94E3EAF0-D998-475B-110D-F125C1BADF40}"/>
+          </ac:spMkLst>
+        </pc:spChg>
+        <pc:spChg chg="add mod ord">
+          <ac:chgData name="KONGKAEW, PUTTIWAT" userId="a8adac1e-848f-4d84-b961-6a7ffb648b49" providerId="ADAL" clId="{F052111D-B225-4361-BF20-F8DD3212B204}" dt="2025-08-27T11:08:43.848" v="144" actId="164"/>
+          <ac:spMkLst>
+            <pc:docMk/>
+            <pc:sldMk cId="2224687866" sldId="268"/>
+            <ac:spMk id="10" creationId="{C925412C-FE44-66DD-28E7-2DC14DFB38C4}"/>
+          </ac:spMkLst>
+        </pc:spChg>
+        <pc:spChg chg="add mod">
+          <ac:chgData name="KONGKAEW, PUTTIWAT" userId="a8adac1e-848f-4d84-b961-6a7ffb648b49" providerId="ADAL" clId="{F052111D-B225-4361-BF20-F8DD3212B204}" dt="2025-08-27T11:06:17.115" v="127" actId="14100"/>
+          <ac:spMkLst>
+            <pc:docMk/>
+            <pc:sldMk cId="2224687866" sldId="268"/>
+            <ac:spMk id="13" creationId="{0E8B5480-DE92-0771-AA8B-6BF98A2A862D}"/>
+          </ac:spMkLst>
+        </pc:spChg>
+        <pc:grpChg chg="add mod">
+          <ac:chgData name="KONGKAEW, PUTTIWAT" userId="a8adac1e-848f-4d84-b961-6a7ffb648b49" providerId="ADAL" clId="{F052111D-B225-4361-BF20-F8DD3212B204}" dt="2025-08-27T11:08:43.848" v="144" actId="164"/>
+          <ac:grpSpMkLst>
+            <pc:docMk/>
+            <pc:sldMk cId="2224687866" sldId="268"/>
+            <ac:grpSpMk id="17" creationId="{EEFB6A19-7C80-54F0-E98F-470AD9F31098}"/>
+          </ac:grpSpMkLst>
+        </pc:grpChg>
+        <pc:cxnChg chg="mod">
+          <ac:chgData name="KONGKAEW, PUTTIWAT" userId="a8adac1e-848f-4d84-b961-6a7ffb648b49" providerId="ADAL" clId="{F052111D-B225-4361-BF20-F8DD3212B204}" dt="2025-08-27T11:09:16.679" v="145" actId="14100"/>
+          <ac:cxnSpMkLst>
+            <pc:docMk/>
+            <pc:sldMk cId="2224687866" sldId="268"/>
+            <ac:cxnSpMk id="11" creationId="{792AEA43-734C-4248-9677-DD285147B35C}"/>
+          </ac:cxnSpMkLst>
+        </pc:cxnChg>
+        <pc:cxnChg chg="mod">
+          <ac:chgData name="KONGKAEW, PUTTIWAT" userId="a8adac1e-848f-4d84-b961-6a7ffb648b49" providerId="ADAL" clId="{F052111D-B225-4361-BF20-F8DD3212B204}" dt="2025-08-27T11:09:19.329" v="146" actId="14100"/>
+          <ac:cxnSpMkLst>
+            <pc:docMk/>
+            <pc:sldMk cId="2224687866" sldId="268"/>
+            <ac:cxnSpMk id="14" creationId="{72911DB9-C16E-D1E4-3EDB-8ADF198FE109}"/>
+          </ac:cxnSpMkLst>
+        </pc:cxnChg>
+      </pc:sldChg>
+      <pc:sldChg chg="addSp delSp modSp new mod">
+        <pc:chgData name="KONGKAEW, PUTTIWAT" userId="a8adac1e-848f-4d84-b961-6a7ffb648b49" providerId="ADAL" clId="{F052111D-B225-4361-BF20-F8DD3212B204}" dt="2025-08-27T11:13:58.428" v="295" actId="1035"/>
+        <pc:sldMkLst>
+          <pc:docMk/>
+          <pc:sldMk cId="3810459738" sldId="277"/>
+        </pc:sldMkLst>
+        <pc:spChg chg="del">
+          <ac:chgData name="KONGKAEW, PUTTIWAT" userId="a8adac1e-848f-4d84-b961-6a7ffb648b49" providerId="ADAL" clId="{F052111D-B225-4361-BF20-F8DD3212B204}" dt="2025-08-27T11:10:38.446" v="149" actId="478"/>
+          <ac:spMkLst>
+            <pc:docMk/>
+            <pc:sldMk cId="3810459738" sldId="277"/>
+            <ac:spMk id="2" creationId="{D72B47E8-F3AF-1977-4E37-5E7E25C572EF}"/>
+          </ac:spMkLst>
+        </pc:spChg>
+        <pc:spChg chg="del">
+          <ac:chgData name="KONGKAEW, PUTTIWAT" userId="a8adac1e-848f-4d84-b961-6a7ffb648b49" providerId="ADAL" clId="{F052111D-B225-4361-BF20-F8DD3212B204}" dt="2025-08-27T11:10:36.818" v="148" actId="478"/>
+          <ac:spMkLst>
+            <pc:docMk/>
+            <pc:sldMk cId="3810459738" sldId="277"/>
+            <ac:spMk id="3" creationId="{30AFFD5A-0A93-8922-2378-39F196EA7541}"/>
+          </ac:spMkLst>
+        </pc:spChg>
+        <pc:spChg chg="add mod">
+          <ac:chgData name="KONGKAEW, PUTTIWAT" userId="a8adac1e-848f-4d84-b961-6a7ffb648b49" providerId="ADAL" clId="{F052111D-B225-4361-BF20-F8DD3212B204}" dt="2025-08-27T11:11:54.930" v="211" actId="122"/>
+          <ac:spMkLst>
+            <pc:docMk/>
+            <pc:sldMk cId="3810459738" sldId="277"/>
+            <ac:spMk id="5" creationId="{BBEB1D0B-2DD5-16F4-1FEC-BB46F82B1B3A}"/>
+          </ac:spMkLst>
+        </pc:spChg>
+        <pc:spChg chg="add mod">
+          <ac:chgData name="KONGKAEW, PUTTIWAT" userId="a8adac1e-848f-4d84-b961-6a7ffb648b49" providerId="ADAL" clId="{F052111D-B225-4361-BF20-F8DD3212B204}" dt="2025-08-27T11:12:31.215" v="265" actId="1036"/>
+          <ac:spMkLst>
+            <pc:docMk/>
+            <pc:sldMk cId="3810459738" sldId="277"/>
+            <ac:spMk id="6" creationId="{269569BB-09EE-3538-0074-FD71C30031B3}"/>
+          </ac:spMkLst>
+        </pc:spChg>
+        <pc:spChg chg="add mod">
+          <ac:chgData name="KONGKAEW, PUTTIWAT" userId="a8adac1e-848f-4d84-b961-6a7ffb648b49" providerId="ADAL" clId="{F052111D-B225-4361-BF20-F8DD3212B204}" dt="2025-08-27T11:13:58.428" v="295" actId="1035"/>
+          <ac:spMkLst>
+            <pc:docMk/>
+            <pc:sldMk cId="3810459738" sldId="277"/>
+            <ac:spMk id="7" creationId="{86216EA6-BC94-13DA-558F-58524D67AB3B}"/>
+          </ac:spMkLst>
+        </pc:spChg>
+        <pc:spChg chg="add mod">
+          <ac:chgData name="KONGKAEW, PUTTIWAT" userId="a8adac1e-848f-4d84-b961-6a7ffb648b49" providerId="ADAL" clId="{F052111D-B225-4361-BF20-F8DD3212B204}" dt="2025-08-27T11:13:15.489" v="283" actId="1076"/>
+          <ac:spMkLst>
+            <pc:docMk/>
+            <pc:sldMk cId="3810459738" sldId="277"/>
+            <ac:spMk id="8" creationId="{05632D6A-FD24-F1DA-FC77-414A936DC3C8}"/>
+          </ac:spMkLst>
+        </pc:spChg>
+        <pc:spChg chg="add mod">
+          <ac:chgData name="KONGKAEW, PUTTIWAT" userId="a8adac1e-848f-4d84-b961-6a7ffb648b49" providerId="ADAL" clId="{F052111D-B225-4361-BF20-F8DD3212B204}" dt="2025-08-27T11:13:23.657" v="294" actId="1038"/>
+          <ac:spMkLst>
+            <pc:docMk/>
+            <pc:sldMk cId="3810459738" sldId="277"/>
+            <ac:spMk id="9" creationId="{0C441AF2-8A36-8CF1-EA6D-870B4DAF435B}"/>
+          </ac:spMkLst>
+        </pc:spChg>
+        <pc:picChg chg="add mod">
+          <ac:chgData name="KONGKAEW, PUTTIWAT" userId="a8adac1e-848f-4d84-b961-6a7ffb648b49" providerId="ADAL" clId="{F052111D-B225-4361-BF20-F8DD3212B204}" dt="2025-08-27T11:10:45.562" v="155" actId="1076"/>
+          <ac:picMkLst>
+            <pc:docMk/>
+            <pc:sldMk cId="3810459738" sldId="277"/>
+            <ac:picMk id="4" creationId="{D12C46A5-852F-3FB9-DD37-C91E8CC621E0}"/>
+          </ac:picMkLst>
+        </pc:picChg>
+      </pc:sldChg>
+    </pc:docChg>
+  </pc:docChgLst>
   <pc:docChgLst>
     <pc:chgData name="KONGKAEW, PUTTIWAT" userId="a8adac1e-848f-4d84-b961-6a7ffb648b49" providerId="ADAL" clId="{2F9C920F-B837-426B-B15A-4F4274BFBB22}"/>
     <pc:docChg chg="undo custSel addSld delSld modSld sldOrd">
@@ -153,22 +321,6 @@
           <pc:docMk/>
           <pc:sldMk cId="1377385226" sldId="256"/>
         </pc:sldMkLst>
-        <pc:spChg chg="mod">
-          <ac:chgData name="KONGKAEW, PUTTIWAT" userId="a8adac1e-848f-4d84-b961-6a7ffb648b49" providerId="ADAL" clId="{2F9C920F-B837-426B-B15A-4F4274BFBB22}" dt="2023-05-19T07:26:33.696" v="58" actId="20577"/>
-          <ac:spMkLst>
-            <pc:docMk/>
-            <pc:sldMk cId="1377385226" sldId="256"/>
-            <ac:spMk id="2" creationId="{B1FCFEA5-F209-9E3C-F823-8A4935D7A412}"/>
-          </ac:spMkLst>
-        </pc:spChg>
-        <pc:spChg chg="mod">
-          <ac:chgData name="KONGKAEW, PUTTIWAT" userId="a8adac1e-848f-4d84-b961-6a7ffb648b49" providerId="ADAL" clId="{2F9C920F-B837-426B-B15A-4F4274BFBB22}" dt="2023-05-19T07:32:31.561" v="502" actId="20577"/>
-          <ac:spMkLst>
-            <pc:docMk/>
-            <pc:sldMk cId="1377385226" sldId="256"/>
-            <ac:spMk id="3" creationId="{786E36B1-8BE0-62FE-C505-EAE387BD19AE}"/>
-          </ac:spMkLst>
-        </pc:spChg>
       </pc:sldChg>
       <pc:sldChg chg="addSp delSp modSp new mod modClrScheme chgLayout">
         <pc:chgData name="KONGKAEW, PUTTIWAT" userId="a8adac1e-848f-4d84-b961-6a7ffb648b49" providerId="ADAL" clId="{2F9C920F-B837-426B-B15A-4F4274BFBB22}" dt="2023-05-19T08:06:55.913" v="1772" actId="27636"/>
@@ -176,38 +328,6 @@
           <pc:docMk/>
           <pc:sldMk cId="941823532" sldId="257"/>
         </pc:sldMkLst>
-        <pc:spChg chg="del mod ord">
-          <ac:chgData name="KONGKAEW, PUTTIWAT" userId="a8adac1e-848f-4d84-b961-6a7ffb648b49" providerId="ADAL" clId="{2F9C920F-B837-426B-B15A-4F4274BFBB22}" dt="2023-05-19T07:27:15.182" v="71" actId="700"/>
-          <ac:spMkLst>
-            <pc:docMk/>
-            <pc:sldMk cId="941823532" sldId="257"/>
-            <ac:spMk id="2" creationId="{58C20DC3-C4E4-D591-E9A3-5B294F4CA083}"/>
-          </ac:spMkLst>
-        </pc:spChg>
-        <pc:spChg chg="del mod ord">
-          <ac:chgData name="KONGKAEW, PUTTIWAT" userId="a8adac1e-848f-4d84-b961-6a7ffb648b49" providerId="ADAL" clId="{2F9C920F-B837-426B-B15A-4F4274BFBB22}" dt="2023-05-19T07:27:15.182" v="71" actId="700"/>
-          <ac:spMkLst>
-            <pc:docMk/>
-            <pc:sldMk cId="941823532" sldId="257"/>
-            <ac:spMk id="3" creationId="{F37B4998-5B31-0E38-F52E-B876B7492E5D}"/>
-          </ac:spMkLst>
-        </pc:spChg>
-        <pc:spChg chg="add mod ord">
-          <ac:chgData name="KONGKAEW, PUTTIWAT" userId="a8adac1e-848f-4d84-b961-6a7ffb648b49" providerId="ADAL" clId="{2F9C920F-B837-426B-B15A-4F4274BFBB22}" dt="2023-05-19T07:27:20.177" v="79" actId="20577"/>
-          <ac:spMkLst>
-            <pc:docMk/>
-            <pc:sldMk cId="941823532" sldId="257"/>
-            <ac:spMk id="4" creationId="{5E81A1FB-969D-CA76-FEC8-ACCEB85F3DB8}"/>
-          </ac:spMkLst>
-        </pc:spChg>
-        <pc:spChg chg="add mod ord">
-          <ac:chgData name="KONGKAEW, PUTTIWAT" userId="a8adac1e-848f-4d84-b961-6a7ffb648b49" providerId="ADAL" clId="{2F9C920F-B837-426B-B15A-4F4274BFBB22}" dt="2023-05-19T08:06:55.913" v="1772" actId="27636"/>
-          <ac:spMkLst>
-            <pc:docMk/>
-            <pc:sldMk cId="941823532" sldId="257"/>
-            <ac:spMk id="5" creationId="{8BF00CE5-67BD-862A-FF10-18676DB6FD04}"/>
-          </ac:spMkLst>
-        </pc:spChg>
       </pc:sldChg>
       <pc:sldChg chg="modSp new mod ord">
         <pc:chgData name="KONGKAEW, PUTTIWAT" userId="a8adac1e-848f-4d84-b961-6a7ffb648b49" providerId="ADAL" clId="{2F9C920F-B837-426B-B15A-4F4274BFBB22}" dt="2023-05-22T10:55:39.939" v="6732"/>
@@ -215,22 +335,6 @@
           <pc:docMk/>
           <pc:sldMk cId="2308169934" sldId="258"/>
         </pc:sldMkLst>
-        <pc:spChg chg="mod">
-          <ac:chgData name="KONGKAEW, PUTTIWAT" userId="a8adac1e-848f-4d84-b961-6a7ffb648b49" providerId="ADAL" clId="{2F9C920F-B837-426B-B15A-4F4274BFBB22}" dt="2023-05-19T08:06:03.303" v="1736" actId="20577"/>
-          <ac:spMkLst>
-            <pc:docMk/>
-            <pc:sldMk cId="2308169934" sldId="258"/>
-            <ac:spMk id="2" creationId="{A38D857D-41FD-0F6A-D9D1-6E13B0259390}"/>
-          </ac:spMkLst>
-        </pc:spChg>
-        <pc:spChg chg="mod">
-          <ac:chgData name="KONGKAEW, PUTTIWAT" userId="a8adac1e-848f-4d84-b961-6a7ffb648b49" providerId="ADAL" clId="{2F9C920F-B837-426B-B15A-4F4274BFBB22}" dt="2023-05-22T10:54:55.506" v="6720" actId="20577"/>
-          <ac:spMkLst>
-            <pc:docMk/>
-            <pc:sldMk cId="2308169934" sldId="258"/>
-            <ac:spMk id="3" creationId="{3307D7C0-2543-AF19-3CA4-6474A75C46DF}"/>
-          </ac:spMkLst>
-        </pc:spChg>
       </pc:sldChg>
       <pc:sldChg chg="modSp new mod ord">
         <pc:chgData name="KONGKAEW, PUTTIWAT" userId="a8adac1e-848f-4d84-b961-6a7ffb648b49" providerId="ADAL" clId="{2F9C920F-B837-426B-B15A-4F4274BFBB22}" dt="2023-05-22T10:55:22.347" v="6730"/>
@@ -238,22 +342,6 @@
           <pc:docMk/>
           <pc:sldMk cId="1589057834" sldId="259"/>
         </pc:sldMkLst>
-        <pc:spChg chg="mod">
-          <ac:chgData name="KONGKAEW, PUTTIWAT" userId="a8adac1e-848f-4d84-b961-6a7ffb648b49" providerId="ADAL" clId="{2F9C920F-B837-426B-B15A-4F4274BFBB22}" dt="2023-05-19T08:05:57.039" v="1724" actId="20577"/>
-          <ac:spMkLst>
-            <pc:docMk/>
-            <pc:sldMk cId="1589057834" sldId="259"/>
-            <ac:spMk id="2" creationId="{5FE116D4-C509-3C55-8C56-52CC2FB3CA33}"/>
-          </ac:spMkLst>
-        </pc:spChg>
-        <pc:spChg chg="mod">
-          <ac:chgData name="KONGKAEW, PUTTIWAT" userId="a8adac1e-848f-4d84-b961-6a7ffb648b49" providerId="ADAL" clId="{2F9C920F-B837-426B-B15A-4F4274BFBB22}" dt="2023-05-22T10:55:06.813" v="6728" actId="20577"/>
-          <ac:spMkLst>
-            <pc:docMk/>
-            <pc:sldMk cId="1589057834" sldId="259"/>
-            <ac:spMk id="3" creationId="{FE022EB8-789B-D109-EE65-E06E89CC074E}"/>
-          </ac:spMkLst>
-        </pc:spChg>
       </pc:sldChg>
       <pc:sldChg chg="addSp modSp new mod">
         <pc:chgData name="KONGKAEW, PUTTIWAT" userId="a8adac1e-848f-4d84-b961-6a7ffb648b49" providerId="ADAL" clId="{2F9C920F-B837-426B-B15A-4F4274BFBB22}" dt="2023-05-22T14:19:52.681" v="7191" actId="403"/>
@@ -261,38 +349,6 @@
           <pc:docMk/>
           <pc:sldMk cId="3512462657" sldId="260"/>
         </pc:sldMkLst>
-        <pc:spChg chg="mod">
-          <ac:chgData name="KONGKAEW, PUTTIWAT" userId="a8adac1e-848f-4d84-b961-6a7ffb648b49" providerId="ADAL" clId="{2F9C920F-B837-426B-B15A-4F4274BFBB22}" dt="2023-05-19T08:07:06.423" v="1806" actId="20577"/>
-          <ac:spMkLst>
-            <pc:docMk/>
-            <pc:sldMk cId="3512462657" sldId="260"/>
-            <ac:spMk id="2" creationId="{7DC9CE02-AB96-8FD1-550A-5EAD190CC38E}"/>
-          </ac:spMkLst>
-        </pc:spChg>
-        <pc:spChg chg="mod">
-          <ac:chgData name="KONGKAEW, PUTTIWAT" userId="a8adac1e-848f-4d84-b961-6a7ffb648b49" providerId="ADAL" clId="{2F9C920F-B837-426B-B15A-4F4274BFBB22}" dt="2023-05-19T08:37:10.809" v="2531" actId="20577"/>
-          <ac:spMkLst>
-            <pc:docMk/>
-            <pc:sldMk cId="3512462657" sldId="260"/>
-            <ac:spMk id="3" creationId="{FB271252-5477-A1BF-5944-6E9250CA12D4}"/>
-          </ac:spMkLst>
-        </pc:spChg>
-        <pc:spChg chg="add mod">
-          <ac:chgData name="KONGKAEW, PUTTIWAT" userId="a8adac1e-848f-4d84-b961-6a7ffb648b49" providerId="ADAL" clId="{2F9C920F-B837-426B-B15A-4F4274BFBB22}" dt="2023-05-22T14:19:52.681" v="7191" actId="403"/>
-          <ac:spMkLst>
-            <pc:docMk/>
-            <pc:sldMk cId="3512462657" sldId="260"/>
-            <ac:spMk id="4" creationId="{2BD8E3D8-D238-127E-0BC5-9F28016659C6}"/>
-          </ac:spMkLst>
-        </pc:spChg>
-        <pc:picChg chg="add mod modCrop">
-          <ac:chgData name="KONGKAEW, PUTTIWAT" userId="a8adac1e-848f-4d84-b961-6a7ffb648b49" providerId="ADAL" clId="{2F9C920F-B837-426B-B15A-4F4274BFBB22}" dt="2023-05-19T08:30:46.708" v="2019" actId="1076"/>
-          <ac:picMkLst>
-            <pc:docMk/>
-            <pc:sldMk cId="3512462657" sldId="260"/>
-            <ac:picMk id="5" creationId="{C068D99A-DD4D-6BE8-9DA1-8CA84F5AAD02}"/>
-          </ac:picMkLst>
-        </pc:picChg>
       </pc:sldChg>
       <pc:sldChg chg="add del">
         <pc:chgData name="KONGKAEW, PUTTIWAT" userId="a8adac1e-848f-4d84-b961-6a7ffb648b49" providerId="ADAL" clId="{2F9C920F-B837-426B-B15A-4F4274BFBB22}" dt="2023-05-19T08:44:21.391" v="2916" actId="47"/>
@@ -307,38 +363,6 @@
           <pc:docMk/>
           <pc:sldMk cId="2826037868" sldId="262"/>
         </pc:sldMkLst>
-        <pc:spChg chg="del mod">
-          <ac:chgData name="KONGKAEW, PUTTIWAT" userId="a8adac1e-848f-4d84-b961-6a7ffb648b49" providerId="ADAL" clId="{2F9C920F-B837-426B-B15A-4F4274BFBB22}" dt="2023-05-19T08:45:38.376" v="2933" actId="478"/>
-          <ac:spMkLst>
-            <pc:docMk/>
-            <pc:sldMk cId="2826037868" sldId="262"/>
-            <ac:spMk id="3" creationId="{FB271252-5477-A1BF-5944-6E9250CA12D4}"/>
-          </ac:spMkLst>
-        </pc:spChg>
-        <pc:spChg chg="add mod">
-          <ac:chgData name="KONGKAEW, PUTTIWAT" userId="a8adac1e-848f-4d84-b961-6a7ffb648b49" providerId="ADAL" clId="{2F9C920F-B837-426B-B15A-4F4274BFBB22}" dt="2023-05-19T09:29:35.129" v="4526" actId="20577"/>
-          <ac:spMkLst>
-            <pc:docMk/>
-            <pc:sldMk cId="2826037868" sldId="262"/>
-            <ac:spMk id="7" creationId="{8470CB3F-8DBB-9E37-1AEE-859874923EEF}"/>
-          </ac:spMkLst>
-        </pc:spChg>
-        <pc:picChg chg="add mod modCrop">
-          <ac:chgData name="KONGKAEW, PUTTIWAT" userId="a8adac1e-848f-4d84-b961-6a7ffb648b49" providerId="ADAL" clId="{2F9C920F-B837-426B-B15A-4F4274BFBB22}" dt="2023-05-19T09:28:35.127" v="4430" actId="1076"/>
-          <ac:picMkLst>
-            <pc:docMk/>
-            <pc:sldMk cId="2826037868" sldId="262"/>
-            <ac:picMk id="4" creationId="{355C15AB-82DB-2A20-DFA3-A9B09D7E2891}"/>
-          </ac:picMkLst>
-        </pc:picChg>
-        <pc:picChg chg="mod modCrop">
-          <ac:chgData name="KONGKAEW, PUTTIWAT" userId="a8adac1e-848f-4d84-b961-6a7ffb648b49" providerId="ADAL" clId="{2F9C920F-B837-426B-B15A-4F4274BFBB22}" dt="2023-05-19T09:28:35.127" v="4430" actId="1076"/>
-          <ac:picMkLst>
-            <pc:docMk/>
-            <pc:sldMk cId="2826037868" sldId="262"/>
-            <ac:picMk id="5" creationId="{C068D99A-DD4D-6BE8-9DA1-8CA84F5AAD02}"/>
-          </ac:picMkLst>
-        </pc:picChg>
       </pc:sldChg>
       <pc:sldChg chg="addSp delSp modSp new mod modClrScheme chgLayout">
         <pc:chgData name="KONGKAEW, PUTTIWAT" userId="a8adac1e-848f-4d84-b961-6a7ffb648b49" providerId="ADAL" clId="{2F9C920F-B837-426B-B15A-4F4274BFBB22}" dt="2023-05-19T08:46:26.111" v="3014" actId="115"/>
@@ -346,86 +370,6 @@
           <pc:docMk/>
           <pc:sldMk cId="4010335364" sldId="263"/>
         </pc:sldMkLst>
-        <pc:spChg chg="mod ord">
-          <ac:chgData name="KONGKAEW, PUTTIWAT" userId="a8adac1e-848f-4d84-b961-6a7ffb648b49" providerId="ADAL" clId="{2F9C920F-B837-426B-B15A-4F4274BFBB22}" dt="2023-05-19T08:32:53.702" v="2166" actId="700"/>
-          <ac:spMkLst>
-            <pc:docMk/>
-            <pc:sldMk cId="4010335364" sldId="263"/>
-            <ac:spMk id="2" creationId="{982045D4-330A-CF77-D36E-471A9BB23AE2}"/>
-          </ac:spMkLst>
-        </pc:spChg>
-        <pc:spChg chg="del">
-          <ac:chgData name="KONGKAEW, PUTTIWAT" userId="a8adac1e-848f-4d84-b961-6a7ffb648b49" providerId="ADAL" clId="{2F9C920F-B837-426B-B15A-4F4274BFBB22}" dt="2023-05-19T08:32:24.291" v="2158"/>
-          <ac:spMkLst>
-            <pc:docMk/>
-            <pc:sldMk cId="4010335364" sldId="263"/>
-            <ac:spMk id="3" creationId="{AA6297C0-74FC-925A-5282-2FFC127BC341}"/>
-          </ac:spMkLst>
-        </pc:spChg>
-        <pc:spChg chg="add del mod ord">
-          <ac:chgData name="KONGKAEW, PUTTIWAT" userId="a8adac1e-848f-4d84-b961-6a7ffb648b49" providerId="ADAL" clId="{2F9C920F-B837-426B-B15A-4F4274BFBB22}" dt="2023-05-19T08:32:53.702" v="2166" actId="700"/>
-          <ac:spMkLst>
-            <pc:docMk/>
-            <pc:sldMk cId="4010335364" sldId="263"/>
-            <ac:spMk id="6" creationId="{47F3AEE8-15FC-3746-4D62-5233228067FF}"/>
-          </ac:spMkLst>
-        </pc:spChg>
-        <pc:spChg chg="add del mod ord">
-          <ac:chgData name="KONGKAEW, PUTTIWAT" userId="a8adac1e-848f-4d84-b961-6a7ffb648b49" providerId="ADAL" clId="{2F9C920F-B837-426B-B15A-4F4274BFBB22}" dt="2023-05-19T08:33:19.617" v="2168"/>
-          <ac:spMkLst>
-            <pc:docMk/>
-            <pc:sldMk cId="4010335364" sldId="263"/>
-            <ac:spMk id="7" creationId="{66E3D461-27ED-8A6A-5FB4-B8B687A5A9BC}"/>
-          </ac:spMkLst>
-        </pc:spChg>
-        <pc:spChg chg="add mod">
-          <ac:chgData name="KONGKAEW, PUTTIWAT" userId="a8adac1e-848f-4d84-b961-6a7ffb648b49" providerId="ADAL" clId="{2F9C920F-B837-426B-B15A-4F4274BFBB22}" dt="2023-05-19T08:46:26.111" v="3014" actId="115"/>
-          <ac:spMkLst>
-            <pc:docMk/>
-            <pc:sldMk cId="4010335364" sldId="263"/>
-            <ac:spMk id="9" creationId="{2DB7ED98-808B-C010-9DA4-7643E791371A}"/>
-          </ac:spMkLst>
-        </pc:spChg>
-        <pc:spChg chg="add mod">
-          <ac:chgData name="KONGKAEW, PUTTIWAT" userId="a8adac1e-848f-4d84-b961-6a7ffb648b49" providerId="ADAL" clId="{2F9C920F-B837-426B-B15A-4F4274BFBB22}" dt="2023-05-19T08:39:00.816" v="2708" actId="1076"/>
-          <ac:spMkLst>
-            <pc:docMk/>
-            <pc:sldMk cId="4010335364" sldId="263"/>
-            <ac:spMk id="19" creationId="{8209912B-7BBE-148B-E38C-AFB5DCB93020}"/>
-          </ac:spMkLst>
-        </pc:spChg>
-        <pc:picChg chg="add del mod ord">
-          <ac:chgData name="KONGKAEW, PUTTIWAT" userId="a8adac1e-848f-4d84-b961-6a7ffb648b49" providerId="ADAL" clId="{2F9C920F-B837-426B-B15A-4F4274BFBB22}" dt="2023-05-19T08:32:54.897" v="2167" actId="478"/>
-          <ac:picMkLst>
-            <pc:docMk/>
-            <pc:sldMk cId="4010335364" sldId="263"/>
-            <ac:picMk id="5" creationId="{363FCA49-5CD2-906F-BCE6-928392724730}"/>
-          </ac:picMkLst>
-        </pc:picChg>
-        <pc:picChg chg="add mod">
-          <ac:chgData name="KONGKAEW, PUTTIWAT" userId="a8adac1e-848f-4d84-b961-6a7ffb648b49" providerId="ADAL" clId="{2F9C920F-B837-426B-B15A-4F4274BFBB22}" dt="2023-05-19T08:33:21.609" v="2169" actId="27614"/>
-          <ac:picMkLst>
-            <pc:docMk/>
-            <pc:sldMk cId="4010335364" sldId="263"/>
-            <ac:picMk id="11" creationId="{A407B89A-8E0C-26A4-3BEE-4CBF052C4176}"/>
-          </ac:picMkLst>
-        </pc:picChg>
-        <pc:cxnChg chg="add mod">
-          <ac:chgData name="KONGKAEW, PUTTIWAT" userId="a8adac1e-848f-4d84-b961-6a7ffb648b49" providerId="ADAL" clId="{2F9C920F-B837-426B-B15A-4F4274BFBB22}" dt="2023-05-19T08:38:39.076" v="2683" actId="14100"/>
-          <ac:cxnSpMkLst>
-            <pc:docMk/>
-            <pc:sldMk cId="4010335364" sldId="263"/>
-            <ac:cxnSpMk id="13" creationId="{4DAB03EB-A88C-4D00-F57C-EF95D19A84E4}"/>
-          </ac:cxnSpMkLst>
-        </pc:cxnChg>
-        <pc:cxnChg chg="add mod">
-          <ac:chgData name="KONGKAEW, PUTTIWAT" userId="a8adac1e-848f-4d84-b961-6a7ffb648b49" providerId="ADAL" clId="{2F9C920F-B837-426B-B15A-4F4274BFBB22}" dt="2023-05-19T08:38:47.378" v="2686" actId="14100"/>
-          <ac:cxnSpMkLst>
-            <pc:docMk/>
-            <pc:sldMk cId="4010335364" sldId="263"/>
-            <ac:cxnSpMk id="16" creationId="{A4BF7EA2-81F2-DE04-DBDA-EB75F16833A8}"/>
-          </ac:cxnSpMkLst>
-        </pc:cxnChg>
       </pc:sldChg>
       <pc:sldChg chg="modSp new mod ord">
         <pc:chgData name="KONGKAEW, PUTTIWAT" userId="a8adac1e-848f-4d84-b961-6a7ffb648b49" providerId="ADAL" clId="{2F9C920F-B837-426B-B15A-4F4274BFBB22}" dt="2023-05-19T08:35:16.642" v="2428" actId="20577"/>
@@ -433,22 +377,6 @@
           <pc:docMk/>
           <pc:sldMk cId="4196541916" sldId="264"/>
         </pc:sldMkLst>
-        <pc:spChg chg="mod">
-          <ac:chgData name="KONGKAEW, PUTTIWAT" userId="a8adac1e-848f-4d84-b961-6a7ffb648b49" providerId="ADAL" clId="{2F9C920F-B837-426B-B15A-4F4274BFBB22}" dt="2023-05-19T08:33:58.992" v="2298" actId="20577"/>
-          <ac:spMkLst>
-            <pc:docMk/>
-            <pc:sldMk cId="4196541916" sldId="264"/>
-            <ac:spMk id="2" creationId="{FA75582B-44AA-052F-4F7D-CB73F3FED7E6}"/>
-          </ac:spMkLst>
-        </pc:spChg>
-        <pc:spChg chg="mod">
-          <ac:chgData name="KONGKAEW, PUTTIWAT" userId="a8adac1e-848f-4d84-b961-6a7ffb648b49" providerId="ADAL" clId="{2F9C920F-B837-426B-B15A-4F4274BFBB22}" dt="2023-05-19T08:35:16.642" v="2428" actId="20577"/>
-          <ac:spMkLst>
-            <pc:docMk/>
-            <pc:sldMk cId="4196541916" sldId="264"/>
-            <ac:spMk id="3" creationId="{1E6A3C6E-D438-3155-AFCB-6BD39A7188CF}"/>
-          </ac:spMkLst>
-        </pc:spChg>
       </pc:sldChg>
       <pc:sldChg chg="addSp delSp modSp new mod">
         <pc:chgData name="KONGKAEW, PUTTIWAT" userId="a8adac1e-848f-4d84-b961-6a7ffb648b49" providerId="ADAL" clId="{2F9C920F-B837-426B-B15A-4F4274BFBB22}" dt="2023-05-22T10:56:39.251" v="6737" actId="403"/>
@@ -456,118 +384,6 @@
           <pc:docMk/>
           <pc:sldMk cId="2311548782" sldId="265"/>
         </pc:sldMkLst>
-        <pc:spChg chg="del">
-          <ac:chgData name="KONGKAEW, PUTTIWAT" userId="a8adac1e-848f-4d84-b961-6a7ffb648b49" providerId="ADAL" clId="{2F9C920F-B837-426B-B15A-4F4274BFBB22}" dt="2023-05-19T08:39:28.199" v="2711"/>
-          <ac:spMkLst>
-            <pc:docMk/>
-            <pc:sldMk cId="2311548782" sldId="265"/>
-            <ac:spMk id="2" creationId="{BFC24DE4-46D1-D9D6-F250-F4912905987A}"/>
-          </ac:spMkLst>
-        </pc:spChg>
-        <pc:spChg chg="del">
-          <ac:chgData name="KONGKAEW, PUTTIWAT" userId="a8adac1e-848f-4d84-b961-6a7ffb648b49" providerId="ADAL" clId="{2F9C920F-B837-426B-B15A-4F4274BFBB22}" dt="2023-05-19T08:39:34.259" v="2714"/>
-          <ac:spMkLst>
-            <pc:docMk/>
-            <pc:sldMk cId="2311548782" sldId="265"/>
-            <ac:spMk id="3" creationId="{54B50896-1F50-E5F6-625C-80BB370C6EB7}"/>
-          </ac:spMkLst>
-        </pc:spChg>
-        <pc:spChg chg="mod">
-          <ac:chgData name="KONGKAEW, PUTTIWAT" userId="a8adac1e-848f-4d84-b961-6a7ffb648b49" providerId="ADAL" clId="{2F9C920F-B837-426B-B15A-4F4274BFBB22}" dt="2023-05-19T08:40:22.775" v="2754" actId="20577"/>
-          <ac:spMkLst>
-            <pc:docMk/>
-            <pc:sldMk cId="2311548782" sldId="265"/>
-            <ac:spMk id="4" creationId="{F6F4724E-6847-3FB2-C7FA-4083CC5BD5A5}"/>
-          </ac:spMkLst>
-        </pc:spChg>
-        <pc:spChg chg="add mod">
-          <ac:chgData name="KONGKAEW, PUTTIWAT" userId="a8adac1e-848f-4d84-b961-6a7ffb648b49" providerId="ADAL" clId="{2F9C920F-B837-426B-B15A-4F4274BFBB22}" dt="2023-05-22T10:56:39.251" v="6737" actId="403"/>
-          <ac:spMkLst>
-            <pc:docMk/>
-            <pc:sldMk cId="2311548782" sldId="265"/>
-            <ac:spMk id="9" creationId="{D1BC6A47-0499-A3D0-D9A4-C1B955594EA2}"/>
-          </ac:spMkLst>
-        </pc:spChg>
-        <pc:spChg chg="add mod">
-          <ac:chgData name="KONGKAEW, PUTTIWAT" userId="a8adac1e-848f-4d84-b961-6a7ffb648b49" providerId="ADAL" clId="{2F9C920F-B837-426B-B15A-4F4274BFBB22}" dt="2023-05-22T10:56:28.718" v="6733" actId="207"/>
-          <ac:spMkLst>
-            <pc:docMk/>
-            <pc:sldMk cId="2311548782" sldId="265"/>
-            <ac:spMk id="14" creationId="{693E4F23-B533-DEED-0D22-63EF93B548F8}"/>
-          </ac:spMkLst>
-        </pc:spChg>
-        <pc:spChg chg="add mod">
-          <ac:chgData name="KONGKAEW, PUTTIWAT" userId="a8adac1e-848f-4d84-b961-6a7ffb648b49" providerId="ADAL" clId="{2F9C920F-B837-426B-B15A-4F4274BFBB22}" dt="2023-05-22T10:56:30.914" v="6734" actId="207"/>
-          <ac:spMkLst>
-            <pc:docMk/>
-            <pc:sldMk cId="2311548782" sldId="265"/>
-            <ac:spMk id="16" creationId="{CFEC5F96-60B7-7CAC-5F7F-853F7FC43516}"/>
-          </ac:spMkLst>
-        </pc:spChg>
-        <pc:spChg chg="add del mod">
-          <ac:chgData name="KONGKAEW, PUTTIWAT" userId="a8adac1e-848f-4d84-b961-6a7ffb648b49" providerId="ADAL" clId="{2F9C920F-B837-426B-B15A-4F4274BFBB22}" dt="2023-05-19T08:43:30.158" v="2865" actId="478"/>
-          <ac:spMkLst>
-            <pc:docMk/>
-            <pc:sldMk cId="2311548782" sldId="265"/>
-            <ac:spMk id="17" creationId="{F2E6DB58-0F3A-6936-565F-2A5FAEDD19F4}"/>
-          </ac:spMkLst>
-        </pc:spChg>
-        <pc:picChg chg="add mod modCrop">
-          <ac:chgData name="KONGKAEW, PUTTIWAT" userId="a8adac1e-848f-4d84-b961-6a7ffb648b49" providerId="ADAL" clId="{2F9C920F-B837-426B-B15A-4F4274BFBB22}" dt="2023-05-19T08:42:59.262" v="2822" actId="1076"/>
-          <ac:picMkLst>
-            <pc:docMk/>
-            <pc:sldMk cId="2311548782" sldId="265"/>
-            <ac:picMk id="6" creationId="{9F9D51E8-F4CD-C453-5281-C565FB49078D}"/>
-          </ac:picMkLst>
-        </pc:picChg>
-        <pc:picChg chg="add mod modCrop">
-          <ac:chgData name="KONGKAEW, PUTTIWAT" userId="a8adac1e-848f-4d84-b961-6a7ffb648b49" providerId="ADAL" clId="{2F9C920F-B837-426B-B15A-4F4274BFBB22}" dt="2023-05-19T08:42:45.057" v="2817" actId="732"/>
-          <ac:picMkLst>
-            <pc:docMk/>
-            <pc:sldMk cId="2311548782" sldId="265"/>
-            <ac:picMk id="8" creationId="{354184CC-52E9-0168-5C61-12D122E147F0}"/>
-          </ac:picMkLst>
-        </pc:picChg>
-        <pc:picChg chg="add mod modCrop">
-          <ac:chgData name="KONGKAEW, PUTTIWAT" userId="a8adac1e-848f-4d84-b961-6a7ffb648b49" providerId="ADAL" clId="{2F9C920F-B837-426B-B15A-4F4274BFBB22}" dt="2023-05-19T08:42:59.262" v="2822" actId="1076"/>
-          <ac:picMkLst>
-            <pc:docMk/>
-            <pc:sldMk cId="2311548782" sldId="265"/>
-            <ac:picMk id="10" creationId="{41C4892F-4BCD-20C1-0285-522737CE71F9}"/>
-          </ac:picMkLst>
-        </pc:picChg>
-        <pc:picChg chg="add mod modCrop">
-          <ac:chgData name="KONGKAEW, PUTTIWAT" userId="a8adac1e-848f-4d84-b961-6a7ffb648b49" providerId="ADAL" clId="{2F9C920F-B837-426B-B15A-4F4274BFBB22}" dt="2023-05-19T08:42:48.950" v="2818" actId="1076"/>
-          <ac:picMkLst>
-            <pc:docMk/>
-            <pc:sldMk cId="2311548782" sldId="265"/>
-            <ac:picMk id="11" creationId="{21FD727B-D7D3-8EDF-998A-3B57D5F55572}"/>
-          </ac:picMkLst>
-        </pc:picChg>
-        <pc:picChg chg="add mod">
-          <ac:chgData name="KONGKAEW, PUTTIWAT" userId="a8adac1e-848f-4d84-b961-6a7ffb648b49" providerId="ADAL" clId="{2F9C920F-B837-426B-B15A-4F4274BFBB22}" dt="2023-05-19T08:42:55.825" v="2821" actId="1076"/>
-          <ac:picMkLst>
-            <pc:docMk/>
-            <pc:sldMk cId="2311548782" sldId="265"/>
-            <ac:picMk id="12" creationId="{5C974149-A5E0-39AB-8322-B3A9F1FC1D29}"/>
-          </ac:picMkLst>
-        </pc:picChg>
-        <pc:picChg chg="add mod">
-          <ac:chgData name="KONGKAEW, PUTTIWAT" userId="a8adac1e-848f-4d84-b961-6a7ffb648b49" providerId="ADAL" clId="{2F9C920F-B837-426B-B15A-4F4274BFBB22}" dt="2023-05-19T08:42:55.825" v="2821" actId="1076"/>
-          <ac:picMkLst>
-            <pc:docMk/>
-            <pc:sldMk cId="2311548782" sldId="265"/>
-            <ac:picMk id="13" creationId="{6E178030-1D75-A012-F387-175324EBAA28}"/>
-          </ac:picMkLst>
-        </pc:picChg>
-        <pc:picChg chg="add del mod">
-          <ac:chgData name="KONGKAEW, PUTTIWAT" userId="a8adac1e-848f-4d84-b961-6a7ffb648b49" providerId="ADAL" clId="{2F9C920F-B837-426B-B15A-4F4274BFBB22}" dt="2023-05-19T08:43:13.125" v="2847"/>
-          <ac:picMkLst>
-            <pc:docMk/>
-            <pc:sldMk cId="2311548782" sldId="265"/>
-            <ac:picMk id="15" creationId="{5DB7E3FD-3E8A-D74A-B4FE-8C32BB7577B6}"/>
-          </ac:picMkLst>
-        </pc:picChg>
       </pc:sldChg>
       <pc:sldChg chg="modSp new del mod modShow">
         <pc:chgData name="KONGKAEW, PUTTIWAT" userId="a8adac1e-848f-4d84-b961-6a7ffb648b49" providerId="ADAL" clId="{2F9C920F-B837-426B-B15A-4F4274BFBB22}" dt="2023-05-22T10:54:38.127" v="6715" actId="47"/>
@@ -575,22 +391,6 @@
           <pc:docMk/>
           <pc:sldMk cId="73811450" sldId="266"/>
         </pc:sldMkLst>
-        <pc:spChg chg="mod">
-          <ac:chgData name="KONGKAEW, PUTTIWAT" userId="a8adac1e-848f-4d84-b961-6a7ffb648b49" providerId="ADAL" clId="{2F9C920F-B837-426B-B15A-4F4274BFBB22}" dt="2023-05-19T08:46:48.580" v="3031" actId="20577"/>
-          <ac:spMkLst>
-            <pc:docMk/>
-            <pc:sldMk cId="73811450" sldId="266"/>
-            <ac:spMk id="2" creationId="{96B9DE51-921E-D3E0-E616-F3C061D61EFE}"/>
-          </ac:spMkLst>
-        </pc:spChg>
-        <pc:spChg chg="mod">
-          <ac:chgData name="KONGKAEW, PUTTIWAT" userId="a8adac1e-848f-4d84-b961-6a7ffb648b49" providerId="ADAL" clId="{2F9C920F-B837-426B-B15A-4F4274BFBB22}" dt="2023-05-19T08:50:21.597" v="3339" actId="20577"/>
-          <ac:spMkLst>
-            <pc:docMk/>
-            <pc:sldMk cId="73811450" sldId="266"/>
-            <ac:spMk id="3" creationId="{24AC48F0-EDF3-6068-0986-DB04C1E45B3E}"/>
-          </ac:spMkLst>
-        </pc:spChg>
       </pc:sldChg>
       <pc:sldChg chg="modSp new del mod">
         <pc:chgData name="KONGKAEW, PUTTIWAT" userId="a8adac1e-848f-4d84-b961-6a7ffb648b49" providerId="ADAL" clId="{2F9C920F-B837-426B-B15A-4F4274BFBB22}" dt="2023-05-19T08:44:19.775" v="2915" actId="47"/>
@@ -598,14 +398,6 @@
           <pc:docMk/>
           <pc:sldMk cId="3018053352" sldId="266"/>
         </pc:sldMkLst>
-        <pc:spChg chg="mod">
-          <ac:chgData name="KONGKAEW, PUTTIWAT" userId="a8adac1e-848f-4d84-b961-6a7ffb648b49" providerId="ADAL" clId="{2F9C920F-B837-426B-B15A-4F4274BFBB22}" dt="2023-05-19T08:44:17.391" v="2914" actId="20577"/>
-          <ac:spMkLst>
-            <pc:docMk/>
-            <pc:sldMk cId="3018053352" sldId="266"/>
-            <ac:spMk id="4" creationId="{C2FEB822-7C15-DD4F-46AF-DA790D9A22D6}"/>
-          </ac:spMkLst>
-        </pc:spChg>
       </pc:sldChg>
       <pc:sldChg chg="modSp new mod">
         <pc:chgData name="KONGKAEW, PUTTIWAT" userId="a8adac1e-848f-4d84-b961-6a7ffb648b49" providerId="ADAL" clId="{2F9C920F-B837-426B-B15A-4F4274BFBB22}" dt="2023-05-19T09:35:56.409" v="5388" actId="20577"/>
@@ -613,22 +405,6 @@
           <pc:docMk/>
           <pc:sldMk cId="2129425839" sldId="267"/>
         </pc:sldMkLst>
-        <pc:spChg chg="mod">
-          <ac:chgData name="KONGKAEW, PUTTIWAT" userId="a8adac1e-848f-4d84-b961-6a7ffb648b49" providerId="ADAL" clId="{2F9C920F-B837-426B-B15A-4F4274BFBB22}" dt="2023-05-19T08:51:01.706" v="3359" actId="20577"/>
-          <ac:spMkLst>
-            <pc:docMk/>
-            <pc:sldMk cId="2129425839" sldId="267"/>
-            <ac:spMk id="2" creationId="{D8689D0A-C7C1-4C13-F0F8-7A59F6EC0D86}"/>
-          </ac:spMkLst>
-        </pc:spChg>
-        <pc:spChg chg="mod">
-          <ac:chgData name="KONGKAEW, PUTTIWAT" userId="a8adac1e-848f-4d84-b961-6a7ffb648b49" providerId="ADAL" clId="{2F9C920F-B837-426B-B15A-4F4274BFBB22}" dt="2023-05-19T09:35:56.409" v="5388" actId="20577"/>
-          <ac:spMkLst>
-            <pc:docMk/>
-            <pc:sldMk cId="2129425839" sldId="267"/>
-            <ac:spMk id="3" creationId="{BCC3803E-6C2F-4F89-873A-33FF5D5F60CC}"/>
-          </ac:spMkLst>
-        </pc:spChg>
       </pc:sldChg>
       <pc:sldChg chg="addSp delSp modSp new mod modClrScheme chgLayout">
         <pc:chgData name="KONGKAEW, PUTTIWAT" userId="a8adac1e-848f-4d84-b961-6a7ffb648b49" providerId="ADAL" clId="{2F9C920F-B837-426B-B15A-4F4274BFBB22}" dt="2023-05-19T11:02:09.536" v="5538" actId="20577"/>
@@ -636,102 +412,6 @@
           <pc:docMk/>
           <pc:sldMk cId="2224687866" sldId="268"/>
         </pc:sldMkLst>
-        <pc:spChg chg="mod ord">
-          <ac:chgData name="KONGKAEW, PUTTIWAT" userId="a8adac1e-848f-4d84-b961-6a7ffb648b49" providerId="ADAL" clId="{2F9C920F-B837-426B-B15A-4F4274BFBB22}" dt="2023-05-19T08:55:13.860" v="3821" actId="700"/>
-          <ac:spMkLst>
-            <pc:docMk/>
-            <pc:sldMk cId="2224687866" sldId="268"/>
-            <ac:spMk id="2" creationId="{96ED4BE1-D869-4DFF-92D7-4722B9555C99}"/>
-          </ac:spMkLst>
-        </pc:spChg>
-        <pc:spChg chg="del">
-          <ac:chgData name="KONGKAEW, PUTTIWAT" userId="a8adac1e-848f-4d84-b961-6a7ffb648b49" providerId="ADAL" clId="{2F9C920F-B837-426B-B15A-4F4274BFBB22}" dt="2023-05-19T08:54:43.023" v="3813"/>
-          <ac:spMkLst>
-            <pc:docMk/>
-            <pc:sldMk cId="2224687866" sldId="268"/>
-            <ac:spMk id="3" creationId="{30A39BC9-C4F4-3874-4E6B-CB5530F95E14}"/>
-          </ac:spMkLst>
-        </pc:spChg>
-        <pc:spChg chg="add del mod ord">
-          <ac:chgData name="KONGKAEW, PUTTIWAT" userId="a8adac1e-848f-4d84-b961-6a7ffb648b49" providerId="ADAL" clId="{2F9C920F-B837-426B-B15A-4F4274BFBB22}" dt="2023-05-19T08:55:17.650" v="3823"/>
-          <ac:spMkLst>
-            <pc:docMk/>
-            <pc:sldMk cId="2224687866" sldId="268"/>
-            <ac:spMk id="6" creationId="{8006A1C2-3F58-1D27-413C-5AD67782FF1D}"/>
-          </ac:spMkLst>
-        </pc:spChg>
-        <pc:spChg chg="add mod">
-          <ac:chgData name="KONGKAEW, PUTTIWAT" userId="a8adac1e-848f-4d84-b961-6a7ffb648b49" providerId="ADAL" clId="{2F9C920F-B837-426B-B15A-4F4274BFBB22}" dt="2023-05-19T09:24:47.972" v="4102" actId="20577"/>
-          <ac:spMkLst>
-            <pc:docMk/>
-            <pc:sldMk cId="2224687866" sldId="268"/>
-            <ac:spMk id="8" creationId="{33FD2692-136B-A8E2-AD6F-8348F9FE9623}"/>
-          </ac:spMkLst>
-        </pc:spChg>
-        <pc:spChg chg="add mod">
-          <ac:chgData name="KONGKAEW, PUTTIWAT" userId="a8adac1e-848f-4d84-b961-6a7ffb648b49" providerId="ADAL" clId="{2F9C920F-B837-426B-B15A-4F4274BFBB22}" dt="2023-05-19T09:24:57.061" v="4104" actId="20577"/>
-          <ac:spMkLst>
-            <pc:docMk/>
-            <pc:sldMk cId="2224687866" sldId="268"/>
-            <ac:spMk id="12" creationId="{2A00F1EC-6D6C-E77F-916D-26EF496055C1}"/>
-          </ac:spMkLst>
-        </pc:spChg>
-        <pc:spChg chg="add mod">
-          <ac:chgData name="KONGKAEW, PUTTIWAT" userId="a8adac1e-848f-4d84-b961-6a7ffb648b49" providerId="ADAL" clId="{2F9C920F-B837-426B-B15A-4F4274BFBB22}" dt="2023-05-19T09:25:19.561" v="4126" actId="20577"/>
-          <ac:spMkLst>
-            <pc:docMk/>
-            <pc:sldMk cId="2224687866" sldId="268"/>
-            <ac:spMk id="15" creationId="{405202DE-4685-6DCA-C502-F74D557BC16F}"/>
-          </ac:spMkLst>
-        </pc:spChg>
-        <pc:spChg chg="add mod">
-          <ac:chgData name="KONGKAEW, PUTTIWAT" userId="a8adac1e-848f-4d84-b961-6a7ffb648b49" providerId="ADAL" clId="{2F9C920F-B837-426B-B15A-4F4274BFBB22}" dt="2023-05-19T11:02:09.536" v="5538" actId="20577"/>
-          <ac:spMkLst>
-            <pc:docMk/>
-            <pc:sldMk cId="2224687866" sldId="268"/>
-            <ac:spMk id="16" creationId="{517A6605-9637-3E0B-FFE0-B92AE7F86E60}"/>
-          </ac:spMkLst>
-        </pc:spChg>
-        <pc:spChg chg="add del mod">
-          <ac:chgData name="KONGKAEW, PUTTIWAT" userId="a8adac1e-848f-4d84-b961-6a7ffb648b49" providerId="ADAL" clId="{2F9C920F-B837-426B-B15A-4F4274BFBB22}" dt="2023-05-19T11:02:02.856" v="5535" actId="478"/>
-          <ac:spMkLst>
-            <pc:docMk/>
-            <pc:sldMk cId="2224687866" sldId="268"/>
-            <ac:spMk id="17" creationId="{58ABFCFF-6E41-AA3C-0B72-013522F8F6DC}"/>
-          </ac:spMkLst>
-        </pc:spChg>
-        <pc:picChg chg="add del mod ord">
-          <ac:chgData name="KONGKAEW, PUTTIWAT" userId="a8adac1e-848f-4d84-b961-6a7ffb648b49" providerId="ADAL" clId="{2F9C920F-B837-426B-B15A-4F4274BFBB22}" dt="2023-05-19T08:55:16.243" v="3822" actId="21"/>
-          <ac:picMkLst>
-            <pc:docMk/>
-            <pc:sldMk cId="2224687866" sldId="268"/>
-            <ac:picMk id="5" creationId="{DAA0C4F3-34E0-275F-BC03-90BACEE2FA34}"/>
-          </ac:picMkLst>
-        </pc:picChg>
-        <pc:picChg chg="add mod">
-          <ac:chgData name="KONGKAEW, PUTTIWAT" userId="a8adac1e-848f-4d84-b961-6a7ffb648b49" providerId="ADAL" clId="{2F9C920F-B837-426B-B15A-4F4274BFBB22}" dt="2023-05-19T08:55:17.650" v="3823"/>
-          <ac:picMkLst>
-            <pc:docMk/>
-            <pc:sldMk cId="2224687866" sldId="268"/>
-            <ac:picMk id="9" creationId="{A14468BA-5426-B2BF-B06C-C3EF064C53C3}"/>
-          </ac:picMkLst>
-        </pc:picChg>
-        <pc:cxnChg chg="add mod">
-          <ac:chgData name="KONGKAEW, PUTTIWAT" userId="a8adac1e-848f-4d84-b961-6a7ffb648b49" providerId="ADAL" clId="{2F9C920F-B837-426B-B15A-4F4274BFBB22}" dt="2023-05-19T09:21:25.912" v="3910" actId="692"/>
-          <ac:cxnSpMkLst>
-            <pc:docMk/>
-            <pc:sldMk cId="2224687866" sldId="268"/>
-            <ac:cxnSpMk id="11" creationId="{792AEA43-734C-4248-9677-DD285147B35C}"/>
-          </ac:cxnSpMkLst>
-        </pc:cxnChg>
-        <pc:cxnChg chg="add mod">
-          <ac:chgData name="KONGKAEW, PUTTIWAT" userId="a8adac1e-848f-4d84-b961-6a7ffb648b49" providerId="ADAL" clId="{2F9C920F-B837-426B-B15A-4F4274BFBB22}" dt="2023-05-19T09:25:10.135" v="4106" actId="692"/>
-          <ac:cxnSpMkLst>
-            <pc:docMk/>
-            <pc:sldMk cId="2224687866" sldId="268"/>
-            <ac:cxnSpMk id="14" creationId="{72911DB9-C16E-D1E4-3EDB-8ADF198FE109}"/>
-          </ac:cxnSpMkLst>
-        </pc:cxnChg>
       </pc:sldChg>
       <pc:sldChg chg="addSp delSp modSp new mod modClrScheme chgLayout">
         <pc:chgData name="KONGKAEW, PUTTIWAT" userId="a8adac1e-848f-4d84-b961-6a7ffb648b49" providerId="ADAL" clId="{2F9C920F-B837-426B-B15A-4F4274BFBB22}" dt="2023-05-19T09:32:17.622" v="4916" actId="20577"/>
@@ -739,38 +419,6 @@
           <pc:docMk/>
           <pc:sldMk cId="2363607066" sldId="269"/>
         </pc:sldMkLst>
-        <pc:spChg chg="del mod ord">
-          <ac:chgData name="KONGKAEW, PUTTIWAT" userId="a8adac1e-848f-4d84-b961-6a7ffb648b49" providerId="ADAL" clId="{2F9C920F-B837-426B-B15A-4F4274BFBB22}" dt="2023-05-19T09:29:52.094" v="4541" actId="700"/>
-          <ac:spMkLst>
-            <pc:docMk/>
-            <pc:sldMk cId="2363607066" sldId="269"/>
-            <ac:spMk id="2" creationId="{F40DF352-EBDB-20CB-FF3E-C0D41B967CEB}"/>
-          </ac:spMkLst>
-        </pc:spChg>
-        <pc:spChg chg="del">
-          <ac:chgData name="KONGKAEW, PUTTIWAT" userId="a8adac1e-848f-4d84-b961-6a7ffb648b49" providerId="ADAL" clId="{2F9C920F-B837-426B-B15A-4F4274BFBB22}" dt="2023-05-19T09:29:52.094" v="4541" actId="700"/>
-          <ac:spMkLst>
-            <pc:docMk/>
-            <pc:sldMk cId="2363607066" sldId="269"/>
-            <ac:spMk id="3" creationId="{7C607F05-5438-7E9D-9ACB-CD15DE373597}"/>
-          </ac:spMkLst>
-        </pc:spChg>
-        <pc:spChg chg="mod ord">
-          <ac:chgData name="KONGKAEW, PUTTIWAT" userId="a8adac1e-848f-4d84-b961-6a7ffb648b49" providerId="ADAL" clId="{2F9C920F-B837-426B-B15A-4F4274BFBB22}" dt="2023-05-19T09:29:52.094" v="4541" actId="700"/>
-          <ac:spMkLst>
-            <pc:docMk/>
-            <pc:sldMk cId="2363607066" sldId="269"/>
-            <ac:spMk id="4" creationId="{6F6F7F8C-C394-98EF-75FD-7F75B6319E97}"/>
-          </ac:spMkLst>
-        </pc:spChg>
-        <pc:spChg chg="add mod ord">
-          <ac:chgData name="KONGKAEW, PUTTIWAT" userId="a8adac1e-848f-4d84-b961-6a7ffb648b49" providerId="ADAL" clId="{2F9C920F-B837-426B-B15A-4F4274BFBB22}" dt="2023-05-19T09:32:17.622" v="4916" actId="20577"/>
-          <ac:spMkLst>
-            <pc:docMk/>
-            <pc:sldMk cId="2363607066" sldId="269"/>
-            <ac:spMk id="5" creationId="{380C93AC-0F2E-02D6-63F8-8C35656FDC00}"/>
-          </ac:spMkLst>
-        </pc:spChg>
       </pc:sldChg>
       <pc:sldChg chg="modSp new mod">
         <pc:chgData name="KONGKAEW, PUTTIWAT" userId="a8adac1e-848f-4d84-b961-6a7ffb648b49" providerId="ADAL" clId="{2F9C920F-B837-426B-B15A-4F4274BFBB22}" dt="2023-05-19T14:28:28.367" v="6284" actId="20577"/>
@@ -778,22 +426,6 @@
           <pc:docMk/>
           <pc:sldMk cId="1627907822" sldId="270"/>
         </pc:sldMkLst>
-        <pc:spChg chg="mod">
-          <ac:chgData name="KONGKAEW, PUTTIWAT" userId="a8adac1e-848f-4d84-b961-6a7ffb648b49" providerId="ADAL" clId="{2F9C920F-B837-426B-B15A-4F4274BFBB22}" dt="2023-05-19T09:32:52.593" v="5012" actId="27636"/>
-          <ac:spMkLst>
-            <pc:docMk/>
-            <pc:sldMk cId="1627907822" sldId="270"/>
-            <ac:spMk id="2" creationId="{73227533-C574-CB4D-29B4-DFEC2E0CBA40}"/>
-          </ac:spMkLst>
-        </pc:spChg>
-        <pc:spChg chg="mod">
-          <ac:chgData name="KONGKAEW, PUTTIWAT" userId="a8adac1e-848f-4d84-b961-6a7ffb648b49" providerId="ADAL" clId="{2F9C920F-B837-426B-B15A-4F4274BFBB22}" dt="2023-05-19T14:28:28.367" v="6284" actId="20577"/>
-          <ac:spMkLst>
-            <pc:docMk/>
-            <pc:sldMk cId="1627907822" sldId="270"/>
-            <ac:spMk id="3" creationId="{306896E1-D6E1-A7A8-EB3C-A03BC49B167D}"/>
-          </ac:spMkLst>
-        </pc:spChg>
       </pc:sldChg>
       <pc:sldChg chg="modSp new mod">
         <pc:chgData name="KONGKAEW, PUTTIWAT" userId="a8adac1e-848f-4d84-b961-6a7ffb648b49" providerId="ADAL" clId="{2F9C920F-B837-426B-B15A-4F4274BFBB22}" dt="2023-05-19T14:28:48.471" v="6329" actId="20577"/>
@@ -801,22 +433,6 @@
           <pc:docMk/>
           <pc:sldMk cId="4182190792" sldId="271"/>
         </pc:sldMkLst>
-        <pc:spChg chg="mod">
-          <ac:chgData name="KONGKAEW, PUTTIWAT" userId="a8adac1e-848f-4d84-b961-6a7ffb648b49" providerId="ADAL" clId="{2F9C920F-B837-426B-B15A-4F4274BFBB22}" dt="2023-05-19T09:36:05.575" v="5403" actId="20577"/>
-          <ac:spMkLst>
-            <pc:docMk/>
-            <pc:sldMk cId="4182190792" sldId="271"/>
-            <ac:spMk id="2" creationId="{56FEF44B-1618-6941-E21B-AD134B5ACBC0}"/>
-          </ac:spMkLst>
-        </pc:spChg>
-        <pc:spChg chg="mod">
-          <ac:chgData name="KONGKAEW, PUTTIWAT" userId="a8adac1e-848f-4d84-b961-6a7ffb648b49" providerId="ADAL" clId="{2F9C920F-B837-426B-B15A-4F4274BFBB22}" dt="2023-05-19T14:28:48.471" v="6329" actId="20577"/>
-          <ac:spMkLst>
-            <pc:docMk/>
-            <pc:sldMk cId="4182190792" sldId="271"/>
-            <ac:spMk id="3" creationId="{25C9FFEA-B0AE-0F88-F7C1-126BFFDD19FD}"/>
-          </ac:spMkLst>
-        </pc:spChg>
       </pc:sldChg>
       <pc:sldChg chg="addSp delSp modSp new mod modShow">
         <pc:chgData name="KONGKAEW, PUTTIWAT" userId="a8adac1e-848f-4d84-b961-6a7ffb648b49" providerId="ADAL" clId="{2F9C920F-B837-426B-B15A-4F4274BFBB22}" dt="2023-05-22T13:44:37.740" v="7149" actId="729"/>
@@ -824,118 +440,6 @@
           <pc:docMk/>
           <pc:sldMk cId="228672105" sldId="272"/>
         </pc:sldMkLst>
-        <pc:spChg chg="mod">
-          <ac:chgData name="KONGKAEW, PUTTIWAT" userId="a8adac1e-848f-4d84-b961-6a7ffb648b49" providerId="ADAL" clId="{2F9C920F-B837-426B-B15A-4F4274BFBB22}" dt="2023-05-19T14:27:31.502" v="6195" actId="20577"/>
-          <ac:spMkLst>
-            <pc:docMk/>
-            <pc:sldMk cId="228672105" sldId="272"/>
-            <ac:spMk id="2" creationId="{9C15383D-38AA-980C-80ED-E182666FF970}"/>
-          </ac:spMkLst>
-        </pc:spChg>
-        <pc:spChg chg="del">
-          <ac:chgData name="KONGKAEW, PUTTIWAT" userId="a8adac1e-848f-4d84-b961-6a7ffb648b49" providerId="ADAL" clId="{2F9C920F-B837-426B-B15A-4F4274BFBB22}" dt="2023-05-19T14:27:26.914" v="6179"/>
-          <ac:spMkLst>
-            <pc:docMk/>
-            <pc:sldMk cId="228672105" sldId="272"/>
-            <ac:spMk id="3" creationId="{2FB79B6D-9E2E-322D-68D3-C98B149F1B7C}"/>
-          </ac:spMkLst>
-        </pc:spChg>
-        <pc:spChg chg="add mod">
-          <ac:chgData name="KONGKAEW, PUTTIWAT" userId="a8adac1e-848f-4d84-b961-6a7ffb648b49" providerId="ADAL" clId="{2F9C920F-B837-426B-B15A-4F4274BFBB22}" dt="2023-05-19T15:41:17.050" v="6678" actId="1076"/>
-          <ac:spMkLst>
-            <pc:docMk/>
-            <pc:sldMk cId="228672105" sldId="272"/>
-            <ac:spMk id="6" creationId="{43DF9946-D0A8-BACE-5B8F-BE07FD057DE2}"/>
-          </ac:spMkLst>
-        </pc:spChg>
-        <pc:spChg chg="add del mod">
-          <ac:chgData name="KONGKAEW, PUTTIWAT" userId="a8adac1e-848f-4d84-b961-6a7ffb648b49" providerId="ADAL" clId="{2F9C920F-B837-426B-B15A-4F4274BFBB22}" dt="2023-05-19T15:40:42.331" v="6621"/>
-          <ac:spMkLst>
-            <pc:docMk/>
-            <pc:sldMk cId="228672105" sldId="272"/>
-            <ac:spMk id="8" creationId="{0D0F7884-C871-9D17-0634-E7B48CD255A2}"/>
-          </ac:spMkLst>
-        </pc:spChg>
-        <pc:spChg chg="add mod">
-          <ac:chgData name="KONGKAEW, PUTTIWAT" userId="a8adac1e-848f-4d84-b961-6a7ffb648b49" providerId="ADAL" clId="{2F9C920F-B837-426B-B15A-4F4274BFBB22}" dt="2023-05-19T15:40:56.474" v="6638" actId="20577"/>
-          <ac:spMkLst>
-            <pc:docMk/>
-            <pc:sldMk cId="228672105" sldId="272"/>
-            <ac:spMk id="11" creationId="{9A7F8552-520A-8BFC-438D-717DA3C8B897}"/>
-          </ac:spMkLst>
-        </pc:spChg>
-        <pc:spChg chg="add mod">
-          <ac:chgData name="KONGKAEW, PUTTIWAT" userId="a8adac1e-848f-4d84-b961-6a7ffb648b49" providerId="ADAL" clId="{2F9C920F-B837-426B-B15A-4F4274BFBB22}" dt="2023-05-19T15:41:04.787" v="6659" actId="20577"/>
-          <ac:spMkLst>
-            <pc:docMk/>
-            <pc:sldMk cId="228672105" sldId="272"/>
-            <ac:spMk id="12" creationId="{E4F8C05F-E020-8EB0-4992-6E972DC50F12}"/>
-          </ac:spMkLst>
-        </pc:spChg>
-        <pc:spChg chg="add mod">
-          <ac:chgData name="KONGKAEW, PUTTIWAT" userId="a8adac1e-848f-4d84-b961-6a7ffb648b49" providerId="ADAL" clId="{2F9C920F-B837-426B-B15A-4F4274BFBB22}" dt="2023-05-22T12:56:02.759" v="7117" actId="20577"/>
-          <ac:spMkLst>
-            <pc:docMk/>
-            <pc:sldMk cId="228672105" sldId="272"/>
-            <ac:spMk id="13" creationId="{B21E3CE0-BB85-2628-242D-9D12A0755B03}"/>
-          </ac:spMkLst>
-        </pc:spChg>
-        <pc:spChg chg="add mod">
-          <ac:chgData name="KONGKAEW, PUTTIWAT" userId="a8adac1e-848f-4d84-b961-6a7ffb648b49" providerId="ADAL" clId="{2F9C920F-B837-426B-B15A-4F4274BFBB22}" dt="2023-05-19T15:42:35.685" v="6694" actId="20577"/>
-          <ac:spMkLst>
-            <pc:docMk/>
-            <pc:sldMk cId="228672105" sldId="272"/>
-            <ac:spMk id="25" creationId="{04C9D661-5CB2-ABD8-0B5A-36A5F88080F8}"/>
-          </ac:spMkLst>
-        </pc:spChg>
-        <pc:picChg chg="add del mod">
-          <ac:chgData name="KONGKAEW, PUTTIWAT" userId="a8adac1e-848f-4d84-b961-6a7ffb648b49" providerId="ADAL" clId="{2F9C920F-B837-426B-B15A-4F4274BFBB22}" dt="2023-05-19T15:09:36.082" v="6620" actId="478"/>
-          <ac:picMkLst>
-            <pc:docMk/>
-            <pc:sldMk cId="228672105" sldId="272"/>
-            <ac:picMk id="5" creationId="{9E7B82DD-938B-D28D-7EFB-867509E9F981}"/>
-          </ac:picMkLst>
-        </pc:picChg>
-        <pc:picChg chg="add mod">
-          <ac:chgData name="KONGKAEW, PUTTIWAT" userId="a8adac1e-848f-4d84-b961-6a7ffb648b49" providerId="ADAL" clId="{2F9C920F-B837-426B-B15A-4F4274BFBB22}" dt="2023-05-19T15:40:48.922" v="6625" actId="14100"/>
-          <ac:picMkLst>
-            <pc:docMk/>
-            <pc:sldMk cId="228672105" sldId="272"/>
-            <ac:picMk id="10" creationId="{E6433B86-FA50-7063-AEEB-6C2061D0F623}"/>
-          </ac:picMkLst>
-        </pc:picChg>
-        <pc:cxnChg chg="add mod">
-          <ac:chgData name="KONGKAEW, PUTTIWAT" userId="a8adac1e-848f-4d84-b961-6a7ffb648b49" providerId="ADAL" clId="{2F9C920F-B837-426B-B15A-4F4274BFBB22}" dt="2023-05-19T15:41:29.420" v="6681" actId="14100"/>
-          <ac:cxnSpMkLst>
-            <pc:docMk/>
-            <pc:sldMk cId="228672105" sldId="272"/>
-            <ac:cxnSpMk id="14" creationId="{1E8CE97E-4742-909A-AA13-E32F341A7478}"/>
-          </ac:cxnSpMkLst>
-        </pc:cxnChg>
-        <pc:cxnChg chg="add mod">
-          <ac:chgData name="KONGKAEW, PUTTIWAT" userId="a8adac1e-848f-4d84-b961-6a7ffb648b49" providerId="ADAL" clId="{2F9C920F-B837-426B-B15A-4F4274BFBB22}" dt="2023-05-19T15:41:56.155" v="6685" actId="14100"/>
-          <ac:cxnSpMkLst>
-            <pc:docMk/>
-            <pc:sldMk cId="228672105" sldId="272"/>
-            <ac:cxnSpMk id="17" creationId="{475EEC1C-C4F6-CD60-098B-6404EBD70E54}"/>
-          </ac:cxnSpMkLst>
-        </pc:cxnChg>
-        <pc:cxnChg chg="add mod">
-          <ac:chgData name="KONGKAEW, PUTTIWAT" userId="a8adac1e-848f-4d84-b961-6a7ffb648b49" providerId="ADAL" clId="{2F9C920F-B837-426B-B15A-4F4274BFBB22}" dt="2023-05-22T12:56:02.759" v="7117" actId="20577"/>
-          <ac:cxnSpMkLst>
-            <pc:docMk/>
-            <pc:sldMk cId="228672105" sldId="272"/>
-            <ac:cxnSpMk id="21" creationId="{BCF2407C-192E-82AD-266A-81523D79ED7C}"/>
-          </ac:cxnSpMkLst>
-        </pc:cxnChg>
-        <pc:cxnChg chg="add mod">
-          <ac:chgData name="KONGKAEW, PUTTIWAT" userId="a8adac1e-848f-4d84-b961-6a7ffb648b49" providerId="ADAL" clId="{2F9C920F-B837-426B-B15A-4F4274BFBB22}" dt="2023-05-19T15:42:54.536" v="6697" actId="14100"/>
-          <ac:cxnSpMkLst>
-            <pc:docMk/>
-            <pc:sldMk cId="228672105" sldId="272"/>
-            <ac:cxnSpMk id="26" creationId="{12EF6CE6-CC78-94B4-A7CB-A4B2AD25238C}"/>
-          </ac:cxnSpMkLst>
-        </pc:cxnChg>
       </pc:sldChg>
       <pc:sldChg chg="modSp new mod">
         <pc:chgData name="KONGKAEW, PUTTIWAT" userId="a8adac1e-848f-4d84-b961-6a7ffb648b49" providerId="ADAL" clId="{2F9C920F-B837-426B-B15A-4F4274BFBB22}" dt="2023-05-22T14:50:01.941" v="7688" actId="20577"/>
@@ -943,22 +447,6 @@
           <pc:docMk/>
           <pc:sldMk cId="3517991577" sldId="273"/>
         </pc:sldMkLst>
-        <pc:spChg chg="mod">
-          <ac:chgData name="KONGKAEW, PUTTIWAT" userId="a8adac1e-848f-4d84-b961-6a7ffb648b49" providerId="ADAL" clId="{2F9C920F-B837-426B-B15A-4F4274BFBB22}" dt="2023-05-22T14:43:52.755" v="7377" actId="20577"/>
-          <ac:spMkLst>
-            <pc:docMk/>
-            <pc:sldMk cId="3517991577" sldId="273"/>
-            <ac:spMk id="2" creationId="{1D2FE50F-59E2-F91B-860F-D486549D775B}"/>
-          </ac:spMkLst>
-        </pc:spChg>
-        <pc:spChg chg="mod">
-          <ac:chgData name="KONGKAEW, PUTTIWAT" userId="a8adac1e-848f-4d84-b961-6a7ffb648b49" providerId="ADAL" clId="{2F9C920F-B837-426B-B15A-4F4274BFBB22}" dt="2023-05-22T14:50:01.941" v="7688" actId="20577"/>
-          <ac:spMkLst>
-            <pc:docMk/>
-            <pc:sldMk cId="3517991577" sldId="273"/>
-            <ac:spMk id="3" creationId="{0C88BBD9-4318-C664-79B4-5DC4019C0B90}"/>
-          </ac:spMkLst>
-        </pc:spChg>
       </pc:sldChg>
       <pc:sldChg chg="addSp delSp modSp add mod">
         <pc:chgData name="KONGKAEW, PUTTIWAT" userId="a8adac1e-848f-4d84-b961-6a7ffb648b49" providerId="ADAL" clId="{2F9C920F-B837-426B-B15A-4F4274BFBB22}" dt="2023-05-22T14:42:09.302" v="7376" actId="207"/>
@@ -966,198 +454,6 @@
           <pc:docMk/>
           <pc:sldMk cId="1700130594" sldId="274"/>
         </pc:sldMkLst>
-        <pc:spChg chg="add del mod">
-          <ac:chgData name="KONGKAEW, PUTTIWAT" userId="a8adac1e-848f-4d84-b961-6a7ffb648b49" providerId="ADAL" clId="{2F9C920F-B837-426B-B15A-4F4274BFBB22}" dt="2023-05-22T10:41:34.272" v="6700"/>
-          <ac:spMkLst>
-            <pc:docMk/>
-            <pc:sldMk cId="1700130594" sldId="274"/>
-            <ac:spMk id="4" creationId="{D2115B99-2F44-F438-8BF7-0A503B85BF6C}"/>
-          </ac:spMkLst>
-        </pc:spChg>
-        <pc:spChg chg="mod">
-          <ac:chgData name="KONGKAEW, PUTTIWAT" userId="a8adac1e-848f-4d84-b961-6a7ffb648b49" providerId="ADAL" clId="{2F9C920F-B837-426B-B15A-4F4274BFBB22}" dt="2023-05-22T10:41:52.334" v="6706" actId="1076"/>
-          <ac:spMkLst>
-            <pc:docMk/>
-            <pc:sldMk cId="1700130594" sldId="274"/>
-            <ac:spMk id="11" creationId="{9A7F8552-520A-8BFC-438D-717DA3C8B897}"/>
-          </ac:spMkLst>
-        </pc:spChg>
-        <pc:spChg chg="mod">
-          <ac:chgData name="KONGKAEW, PUTTIWAT" userId="a8adac1e-848f-4d84-b961-6a7ffb648b49" providerId="ADAL" clId="{2F9C920F-B837-426B-B15A-4F4274BFBB22}" dt="2023-05-22T10:42:02.945" v="6707" actId="1076"/>
-          <ac:spMkLst>
-            <pc:docMk/>
-            <pc:sldMk cId="1700130594" sldId="274"/>
-            <ac:spMk id="12" creationId="{E4F8C05F-E020-8EB0-4992-6E972DC50F12}"/>
-          </ac:spMkLst>
-        </pc:spChg>
-        <pc:spChg chg="mod">
-          <ac:chgData name="KONGKAEW, PUTTIWAT" userId="a8adac1e-848f-4d84-b961-6a7ffb648b49" providerId="ADAL" clId="{2F9C920F-B837-426B-B15A-4F4274BFBB22}" dt="2023-05-22T12:55:52.759" v="7103" actId="20577"/>
-          <ac:spMkLst>
-            <pc:docMk/>
-            <pc:sldMk cId="1700130594" sldId="274"/>
-            <ac:spMk id="13" creationId="{B21E3CE0-BB85-2628-242D-9D12A0755B03}"/>
-          </ac:spMkLst>
-        </pc:spChg>
-        <pc:spChg chg="mod">
-          <ac:chgData name="KONGKAEW, PUTTIWAT" userId="a8adac1e-848f-4d84-b961-6a7ffb648b49" providerId="ADAL" clId="{2F9C920F-B837-426B-B15A-4F4274BFBB22}" dt="2023-05-22T10:42:45.244" v="6712" actId="14100"/>
-          <ac:spMkLst>
-            <pc:docMk/>
-            <pc:sldMk cId="1700130594" sldId="274"/>
-            <ac:spMk id="25" creationId="{04C9D661-5CB2-ABD8-0B5A-36A5F88080F8}"/>
-          </ac:spMkLst>
-        </pc:spChg>
-        <pc:spChg chg="add del mod">
-          <ac:chgData name="KONGKAEW, PUTTIWAT" userId="a8adac1e-848f-4d84-b961-6a7ffb648b49" providerId="ADAL" clId="{2F9C920F-B837-426B-B15A-4F4274BFBB22}" dt="2023-05-22T12:51:47.737" v="6794" actId="478"/>
-          <ac:spMkLst>
-            <pc:docMk/>
-            <pc:sldMk cId="1700130594" sldId="274"/>
-            <ac:spMk id="31" creationId="{9E513A5A-6AA7-AA2A-F615-AEB2D538A2EF}"/>
-          </ac:spMkLst>
-        </pc:spChg>
-        <pc:spChg chg="add del mod">
-          <ac:chgData name="KONGKAEW, PUTTIWAT" userId="a8adac1e-848f-4d84-b961-6a7ffb648b49" providerId="ADAL" clId="{2F9C920F-B837-426B-B15A-4F4274BFBB22}" dt="2023-05-22T12:51:47.737" v="6794" actId="478"/>
-          <ac:spMkLst>
-            <pc:docMk/>
-            <pc:sldMk cId="1700130594" sldId="274"/>
-            <ac:spMk id="32" creationId="{BDB47CF9-1691-68C8-EA10-59363EC2BF43}"/>
-          </ac:spMkLst>
-        </pc:spChg>
-        <pc:spChg chg="add mod">
-          <ac:chgData name="KONGKAEW, PUTTIWAT" userId="a8adac1e-848f-4d84-b961-6a7ffb648b49" providerId="ADAL" clId="{2F9C920F-B837-426B-B15A-4F4274BFBB22}" dt="2023-05-22T12:55:07.280" v="7087" actId="20577"/>
-          <ac:spMkLst>
-            <pc:docMk/>
-            <pc:sldMk cId="1700130594" sldId="274"/>
-            <ac:spMk id="33" creationId="{C91A1DDE-3A9A-1146-39A6-784A41BD5174}"/>
-          </ac:spMkLst>
-        </pc:spChg>
-        <pc:spChg chg="add mod">
-          <ac:chgData name="KONGKAEW, PUTTIWAT" userId="a8adac1e-848f-4d84-b961-6a7ffb648b49" providerId="ADAL" clId="{2F9C920F-B837-426B-B15A-4F4274BFBB22}" dt="2023-05-22T14:33:53.325" v="7249" actId="20577"/>
-          <ac:spMkLst>
-            <pc:docMk/>
-            <pc:sldMk cId="1700130594" sldId="274"/>
-            <ac:spMk id="34" creationId="{848B1A58-EEEE-7E68-6B2E-F773815F4C6C}"/>
-          </ac:spMkLst>
-        </pc:spChg>
-        <pc:spChg chg="add mod">
-          <ac:chgData name="KONGKAEW, PUTTIWAT" userId="a8adac1e-848f-4d84-b961-6a7ffb648b49" providerId="ADAL" clId="{2F9C920F-B837-426B-B15A-4F4274BFBB22}" dt="2023-05-22T14:37:20.334" v="7304" actId="207"/>
-          <ac:spMkLst>
-            <pc:docMk/>
-            <pc:sldMk cId="1700130594" sldId="274"/>
-            <ac:spMk id="35" creationId="{73611E5E-803F-0B4D-B854-E89546432B3B}"/>
-          </ac:spMkLst>
-        </pc:spChg>
-        <pc:spChg chg="add mod">
-          <ac:chgData name="KONGKAEW, PUTTIWAT" userId="a8adac1e-848f-4d84-b961-6a7ffb648b49" providerId="ADAL" clId="{2F9C920F-B837-426B-B15A-4F4274BFBB22}" dt="2023-05-22T14:42:09.302" v="7376" actId="207"/>
-          <ac:spMkLst>
-            <pc:docMk/>
-            <pc:sldMk cId="1700130594" sldId="274"/>
-            <ac:spMk id="38" creationId="{46D7D797-F7C9-390A-195B-2ED85755498E}"/>
-          </ac:spMkLst>
-        </pc:spChg>
-        <pc:spChg chg="add mod">
-          <ac:chgData name="KONGKAEW, PUTTIWAT" userId="a8adac1e-848f-4d84-b961-6a7ffb648b49" providerId="ADAL" clId="{2F9C920F-B837-426B-B15A-4F4274BFBB22}" dt="2023-05-22T14:40:41.781" v="7371" actId="207"/>
-          <ac:spMkLst>
-            <pc:docMk/>
-            <pc:sldMk cId="1700130594" sldId="274"/>
-            <ac:spMk id="42" creationId="{7B6087D4-9C65-50F0-74CB-DF4CCACB9CD2}"/>
-          </ac:spMkLst>
-        </pc:spChg>
-        <pc:picChg chg="add mod ord">
-          <ac:chgData name="KONGKAEW, PUTTIWAT" userId="a8adac1e-848f-4d84-b961-6a7ffb648b49" providerId="ADAL" clId="{2F9C920F-B837-426B-B15A-4F4274BFBB22}" dt="2023-05-22T14:00:02.713" v="7151" actId="1076"/>
-          <ac:picMkLst>
-            <pc:docMk/>
-            <pc:sldMk cId="1700130594" sldId="274"/>
-            <ac:picMk id="7" creationId="{85815A96-320B-70FB-7496-74C6D208519E}"/>
-          </ac:picMkLst>
-        </pc:picChg>
-        <pc:picChg chg="del">
-          <ac:chgData name="KONGKAEW, PUTTIWAT" userId="a8adac1e-848f-4d84-b961-6a7ffb648b49" providerId="ADAL" clId="{2F9C920F-B837-426B-B15A-4F4274BFBB22}" dt="2023-05-22T10:40:23.762" v="6699" actId="478"/>
-          <ac:picMkLst>
-            <pc:docMk/>
-            <pc:sldMk cId="1700130594" sldId="274"/>
-            <ac:picMk id="10" creationId="{E6433B86-FA50-7063-AEEB-6C2061D0F623}"/>
-          </ac:picMkLst>
-        </pc:picChg>
-        <pc:picChg chg="add del mod">
-          <ac:chgData name="KONGKAEW, PUTTIWAT" userId="a8adac1e-848f-4d84-b961-6a7ffb648b49" providerId="ADAL" clId="{2F9C920F-B837-426B-B15A-4F4274BFBB22}" dt="2023-05-22T12:47:19.200" v="6741" actId="478"/>
-          <ac:picMkLst>
-            <pc:docMk/>
-            <pc:sldMk cId="1700130594" sldId="274"/>
-            <ac:picMk id="20" creationId="{10743222-D5C5-A2A9-CE4D-507B429BF83D}"/>
-          </ac:picMkLst>
-        </pc:picChg>
-        <pc:picChg chg="add del mod">
-          <ac:chgData name="KONGKAEW, PUTTIWAT" userId="a8adac1e-848f-4d84-b961-6a7ffb648b49" providerId="ADAL" clId="{2F9C920F-B837-426B-B15A-4F4274BFBB22}" dt="2023-05-22T12:51:47.737" v="6794" actId="478"/>
-          <ac:picMkLst>
-            <pc:docMk/>
-            <pc:sldMk cId="1700130594" sldId="274"/>
-            <ac:picMk id="23" creationId="{C3979CA3-5ED5-AEAD-701E-38F216858D92}"/>
-          </ac:picMkLst>
-        </pc:picChg>
-        <pc:cxnChg chg="mod">
-          <ac:chgData name="KONGKAEW, PUTTIWAT" userId="a8adac1e-848f-4d84-b961-6a7ffb648b49" providerId="ADAL" clId="{2F9C920F-B837-426B-B15A-4F4274BFBB22}" dt="2023-05-22T10:41:52.334" v="6706" actId="1076"/>
-          <ac:cxnSpMkLst>
-            <pc:docMk/>
-            <pc:sldMk cId="1700130594" sldId="274"/>
-            <ac:cxnSpMk id="14" creationId="{1E8CE97E-4742-909A-AA13-E32F341A7478}"/>
-          </ac:cxnSpMkLst>
-        </pc:cxnChg>
-        <pc:cxnChg chg="mod">
-          <ac:chgData name="KONGKAEW, PUTTIWAT" userId="a8adac1e-848f-4d84-b961-6a7ffb648b49" providerId="ADAL" clId="{2F9C920F-B837-426B-B15A-4F4274BFBB22}" dt="2023-05-22T10:42:02.945" v="6707" actId="1076"/>
-          <ac:cxnSpMkLst>
-            <pc:docMk/>
-            <pc:sldMk cId="1700130594" sldId="274"/>
-            <ac:cxnSpMk id="17" creationId="{475EEC1C-C4F6-CD60-098B-6404EBD70E54}"/>
-          </ac:cxnSpMkLst>
-        </pc:cxnChg>
-        <pc:cxnChg chg="mod">
-          <ac:chgData name="KONGKAEW, PUTTIWAT" userId="a8adac1e-848f-4d84-b961-6a7ffb648b49" providerId="ADAL" clId="{2F9C920F-B837-426B-B15A-4F4274BFBB22}" dt="2023-05-22T12:55:49.151" v="7089" actId="20577"/>
-          <ac:cxnSpMkLst>
-            <pc:docMk/>
-            <pc:sldMk cId="1700130594" sldId="274"/>
-            <ac:cxnSpMk id="21" creationId="{BCF2407C-192E-82AD-266A-81523D79ED7C}"/>
-          </ac:cxnSpMkLst>
-        </pc:cxnChg>
-        <pc:cxnChg chg="mod">
-          <ac:chgData name="KONGKAEW, PUTTIWAT" userId="a8adac1e-848f-4d84-b961-6a7ffb648b49" providerId="ADAL" clId="{2F9C920F-B837-426B-B15A-4F4274BFBB22}" dt="2023-05-22T10:42:45.244" v="6712" actId="14100"/>
-          <ac:cxnSpMkLst>
-            <pc:docMk/>
-            <pc:sldMk cId="1700130594" sldId="274"/>
-            <ac:cxnSpMk id="26" creationId="{12EF6CE6-CC78-94B4-A7CB-A4B2AD25238C}"/>
-          </ac:cxnSpMkLst>
-        </pc:cxnChg>
-        <pc:cxnChg chg="add del">
-          <ac:chgData name="KONGKAEW, PUTTIWAT" userId="a8adac1e-848f-4d84-b961-6a7ffb648b49" providerId="ADAL" clId="{2F9C920F-B837-426B-B15A-4F4274BFBB22}" dt="2023-05-22T12:49:16.212" v="6750" actId="21"/>
-          <ac:cxnSpMkLst>
-            <pc:docMk/>
-            <pc:sldMk cId="1700130594" sldId="274"/>
-            <ac:cxnSpMk id="27" creationId="{EB942854-06E5-37E8-D8A6-0310502B4596}"/>
-          </ac:cxnSpMkLst>
-        </pc:cxnChg>
-        <pc:cxnChg chg="add del mod">
-          <ac:chgData name="KONGKAEW, PUTTIWAT" userId="a8adac1e-848f-4d84-b961-6a7ffb648b49" providerId="ADAL" clId="{2F9C920F-B837-426B-B15A-4F4274BFBB22}" dt="2023-05-22T12:51:47.737" v="6794" actId="478"/>
-          <ac:cxnSpMkLst>
-            <pc:docMk/>
-            <pc:sldMk cId="1700130594" sldId="274"/>
-            <ac:cxnSpMk id="28" creationId="{981B3EB8-AA1C-5629-D4AD-FBEA5B4D106D}"/>
-          </ac:cxnSpMkLst>
-        </pc:cxnChg>
-        <pc:cxnChg chg="add">
-          <ac:chgData name="KONGKAEW, PUTTIWAT" userId="a8adac1e-848f-4d84-b961-6a7ffb648b49" providerId="ADAL" clId="{2F9C920F-B837-426B-B15A-4F4274BFBB22}" dt="2023-05-22T14:38:57.204" v="7305" actId="11529"/>
-          <ac:cxnSpMkLst>
-            <pc:docMk/>
-            <pc:sldMk cId="1700130594" sldId="274"/>
-            <ac:cxnSpMk id="37" creationId="{434B670B-A4E9-FE66-2B14-DD4440328F24}"/>
-          </ac:cxnSpMkLst>
-        </pc:cxnChg>
-        <pc:cxnChg chg="add mod">
-          <ac:chgData name="KONGKAEW, PUTTIWAT" userId="a8adac1e-848f-4d84-b961-6a7ffb648b49" providerId="ADAL" clId="{2F9C920F-B837-426B-B15A-4F4274BFBB22}" dt="2023-05-22T14:40:27.989" v="7358" actId="14100"/>
-          <ac:cxnSpMkLst>
-            <pc:docMk/>
-            <pc:sldMk cId="1700130594" sldId="274"/>
-            <ac:cxnSpMk id="40" creationId="{8F15C6BF-7A11-432F-E305-4A6C4FA7E448}"/>
-          </ac:cxnSpMkLst>
-        </pc:cxnChg>
       </pc:sldChg>
       <pc:sldChg chg="addSp delSp modSp add mod modShow">
         <pc:chgData name="KONGKAEW, PUTTIWAT" userId="a8adac1e-848f-4d84-b961-6a7ffb648b49" providerId="ADAL" clId="{2F9C920F-B837-426B-B15A-4F4274BFBB22}" dt="2023-05-22T12:57:53.849" v="7148" actId="20577"/>
@@ -1165,54 +461,6 @@
           <pc:docMk/>
           <pc:sldMk cId="305923836" sldId="275"/>
         </pc:sldMkLst>
-        <pc:spChg chg="add mod">
-          <ac:chgData name="KONGKAEW, PUTTIWAT" userId="a8adac1e-848f-4d84-b961-6a7ffb648b49" providerId="ADAL" clId="{2F9C920F-B837-426B-B15A-4F4274BFBB22}" dt="2023-05-22T12:57:43.694" v="7144" actId="20577"/>
-          <ac:spMkLst>
-            <pc:docMk/>
-            <pc:sldMk cId="305923836" sldId="275"/>
-            <ac:spMk id="5" creationId="{8B300086-D99D-BE74-44F0-3BD946CCB3B7}"/>
-          </ac:spMkLst>
-        </pc:spChg>
-        <pc:spChg chg="mod">
-          <ac:chgData name="KONGKAEW, PUTTIWAT" userId="a8adac1e-848f-4d84-b961-6a7ffb648b49" providerId="ADAL" clId="{2F9C920F-B837-426B-B15A-4F4274BFBB22}" dt="2023-05-22T12:57:53.849" v="7148" actId="20577"/>
-          <ac:spMkLst>
-            <pc:docMk/>
-            <pc:sldMk cId="305923836" sldId="275"/>
-            <ac:spMk id="13" creationId="{B21E3CE0-BB85-2628-242D-9D12A0755B03}"/>
-          </ac:spMkLst>
-        </pc:spChg>
-        <pc:spChg chg="mod">
-          <ac:chgData name="KONGKAEW, PUTTIWAT" userId="a8adac1e-848f-4d84-b961-6a7ffb648b49" providerId="ADAL" clId="{2F9C920F-B837-426B-B15A-4F4274BFBB22}" dt="2023-05-22T12:53:31.042" v="6884" actId="1076"/>
-          <ac:spMkLst>
-            <pc:docMk/>
-            <pc:sldMk cId="305923836" sldId="275"/>
-            <ac:spMk id="32" creationId="{BDB47CF9-1691-68C8-EA10-59363EC2BF43}"/>
-          </ac:spMkLst>
-        </pc:spChg>
-        <pc:cxnChg chg="add del">
-          <ac:chgData name="KONGKAEW, PUTTIWAT" userId="a8adac1e-848f-4d84-b961-6a7ffb648b49" providerId="ADAL" clId="{2F9C920F-B837-426B-B15A-4F4274BFBB22}" dt="2023-05-22T12:57:12.712" v="7132" actId="11529"/>
-          <ac:cxnSpMkLst>
-            <pc:docMk/>
-            <pc:sldMk cId="305923836" sldId="275"/>
-            <ac:cxnSpMk id="4" creationId="{AAA89797-4A85-9C05-58A0-4E3CA4790E96}"/>
-          </ac:cxnSpMkLst>
-        </pc:cxnChg>
-        <pc:cxnChg chg="add mod">
-          <ac:chgData name="KONGKAEW, PUTTIWAT" userId="a8adac1e-848f-4d84-b961-6a7ffb648b49" providerId="ADAL" clId="{2F9C920F-B837-426B-B15A-4F4274BFBB22}" dt="2023-05-22T12:57:38.099" v="7141" actId="14100"/>
-          <ac:cxnSpMkLst>
-            <pc:docMk/>
-            <pc:sldMk cId="305923836" sldId="275"/>
-            <ac:cxnSpMk id="8" creationId="{F08313DB-D093-24B6-12FB-6D166D21FC25}"/>
-          </ac:cxnSpMkLst>
-        </pc:cxnChg>
-        <pc:cxnChg chg="mod">
-          <ac:chgData name="KONGKAEW, PUTTIWAT" userId="a8adac1e-848f-4d84-b961-6a7ffb648b49" providerId="ADAL" clId="{2F9C920F-B837-426B-B15A-4F4274BFBB22}" dt="2023-05-22T12:56:59.031" v="7119" actId="20577"/>
-          <ac:cxnSpMkLst>
-            <pc:docMk/>
-            <pc:sldMk cId="305923836" sldId="275"/>
-            <ac:cxnSpMk id="21" creationId="{BCF2407C-192E-82AD-266A-81523D79ED7C}"/>
-          </ac:cxnSpMkLst>
-        </pc:cxnChg>
       </pc:sldChg>
       <pc:sldChg chg="addSp delSp modSp add mod">
         <pc:chgData name="KONGKAEW, PUTTIWAT" userId="a8adac1e-848f-4d84-b961-6a7ffb648b49" providerId="ADAL" clId="{2F9C920F-B837-426B-B15A-4F4274BFBB22}" dt="2023-05-23T11:11:11.964" v="7741" actId="20577"/>
@@ -1220,102 +468,6 @@
           <pc:docMk/>
           <pc:sldMk cId="416478540" sldId="276"/>
         </pc:sldMkLst>
-        <pc:spChg chg="add del mod">
-          <ac:chgData name="KONGKAEW, PUTTIWAT" userId="a8adac1e-848f-4d84-b961-6a7ffb648b49" providerId="ADAL" clId="{2F9C920F-B837-426B-B15A-4F4274BFBB22}" dt="2023-05-23T11:08:25.732" v="7691"/>
-          <ac:spMkLst>
-            <pc:docMk/>
-            <pc:sldMk cId="416478540" sldId="276"/>
-            <ac:spMk id="4" creationId="{38027BAE-26BC-7F8A-22A3-5A8AC8E9C6C6}"/>
-          </ac:spMkLst>
-        </pc:spChg>
-        <pc:spChg chg="mod">
-          <ac:chgData name="KONGKAEW, PUTTIWAT" userId="a8adac1e-848f-4d84-b961-6a7ffb648b49" providerId="ADAL" clId="{2F9C920F-B837-426B-B15A-4F4274BFBB22}" dt="2023-05-23T11:10:32.498" v="7708" actId="20577"/>
-          <ac:spMkLst>
-            <pc:docMk/>
-            <pc:sldMk cId="416478540" sldId="276"/>
-            <ac:spMk id="12" creationId="{E4F8C05F-E020-8EB0-4992-6E972DC50F12}"/>
-          </ac:spMkLst>
-        </pc:spChg>
-        <pc:spChg chg="del">
-          <ac:chgData name="KONGKAEW, PUTTIWAT" userId="a8adac1e-848f-4d84-b961-6a7ffb648b49" providerId="ADAL" clId="{2F9C920F-B837-426B-B15A-4F4274BFBB22}" dt="2023-05-23T11:10:27.762" v="7705" actId="478"/>
-          <ac:spMkLst>
-            <pc:docMk/>
-            <pc:sldMk cId="416478540" sldId="276"/>
-            <ac:spMk id="13" creationId="{B21E3CE0-BB85-2628-242D-9D12A0755B03}"/>
-          </ac:spMkLst>
-        </pc:spChg>
-        <pc:spChg chg="del">
-          <ac:chgData name="KONGKAEW, PUTTIWAT" userId="a8adac1e-848f-4d84-b961-6a7ffb648b49" providerId="ADAL" clId="{2F9C920F-B837-426B-B15A-4F4274BFBB22}" dt="2023-05-23T11:10:41.526" v="7710" actId="478"/>
-          <ac:spMkLst>
-            <pc:docMk/>
-            <pc:sldMk cId="416478540" sldId="276"/>
-            <ac:spMk id="25" creationId="{04C9D661-5CB2-ABD8-0B5A-36A5F88080F8}"/>
-          </ac:spMkLst>
-        </pc:spChg>
-        <pc:spChg chg="mod">
-          <ac:chgData name="KONGKAEW, PUTTIWAT" userId="a8adac1e-848f-4d84-b961-6a7ffb648b49" providerId="ADAL" clId="{2F9C920F-B837-426B-B15A-4F4274BFBB22}" dt="2023-05-23T11:11:11.964" v="7741" actId="20577"/>
-          <ac:spMkLst>
-            <pc:docMk/>
-            <pc:sldMk cId="416478540" sldId="276"/>
-            <ac:spMk id="34" creationId="{848B1A58-EEEE-7E68-6B2E-F773815F4C6C}"/>
-          </ac:spMkLst>
-        </pc:spChg>
-        <pc:spChg chg="mod">
-          <ac:chgData name="KONGKAEW, PUTTIWAT" userId="a8adac1e-848f-4d84-b961-6a7ffb648b49" providerId="ADAL" clId="{2F9C920F-B837-426B-B15A-4F4274BFBB22}" dt="2023-05-23T11:10:53.281" v="7728" actId="20577"/>
-          <ac:spMkLst>
-            <pc:docMk/>
-            <pc:sldMk cId="416478540" sldId="276"/>
-            <ac:spMk id="38" creationId="{46D7D797-F7C9-390A-195B-2ED85755498E}"/>
-          </ac:spMkLst>
-        </pc:spChg>
-        <pc:picChg chg="del">
-          <ac:chgData name="KONGKAEW, PUTTIWAT" userId="a8adac1e-848f-4d84-b961-6a7ffb648b49" providerId="ADAL" clId="{2F9C920F-B837-426B-B15A-4F4274BFBB22}" dt="2023-05-23T11:08:19.114" v="7690" actId="478"/>
-          <ac:picMkLst>
-            <pc:docMk/>
-            <pc:sldMk cId="416478540" sldId="276"/>
-            <ac:picMk id="7" creationId="{85815A96-320B-70FB-7496-74C6D208519E}"/>
-          </ac:picMkLst>
-        </pc:picChg>
-        <pc:picChg chg="add mod ord">
-          <ac:chgData name="KONGKAEW, PUTTIWAT" userId="a8adac1e-848f-4d84-b961-6a7ffb648b49" providerId="ADAL" clId="{2F9C920F-B837-426B-B15A-4F4274BFBB22}" dt="2023-05-23T11:09:26.229" v="7702" actId="1076"/>
-          <ac:picMkLst>
-            <pc:docMk/>
-            <pc:sldMk cId="416478540" sldId="276"/>
-            <ac:picMk id="8" creationId="{A9990D27-8F06-EA45-443B-CFC54DCB4E44}"/>
-          </ac:picMkLst>
-        </pc:picChg>
-        <pc:cxnChg chg="mod">
-          <ac:chgData name="KONGKAEW, PUTTIWAT" userId="a8adac1e-848f-4d84-b961-6a7ffb648b49" providerId="ADAL" clId="{2F9C920F-B837-426B-B15A-4F4274BFBB22}" dt="2023-05-23T11:10:37.023" v="7709" actId="14100"/>
-          <ac:cxnSpMkLst>
-            <pc:docMk/>
-            <pc:sldMk cId="416478540" sldId="276"/>
-            <ac:cxnSpMk id="17" creationId="{475EEC1C-C4F6-CD60-098B-6404EBD70E54}"/>
-          </ac:cxnSpMkLst>
-        </pc:cxnChg>
-        <pc:cxnChg chg="del mod">
-          <ac:chgData name="KONGKAEW, PUTTIWAT" userId="a8adac1e-848f-4d84-b961-6a7ffb648b49" providerId="ADAL" clId="{2F9C920F-B837-426B-B15A-4F4274BFBB22}" dt="2023-05-23T11:10:27.762" v="7705" actId="478"/>
-          <ac:cxnSpMkLst>
-            <pc:docMk/>
-            <pc:sldMk cId="416478540" sldId="276"/>
-            <ac:cxnSpMk id="21" creationId="{BCF2407C-192E-82AD-266A-81523D79ED7C}"/>
-          </ac:cxnSpMkLst>
-        </pc:cxnChg>
-        <pc:cxnChg chg="del mod">
-          <ac:chgData name="KONGKAEW, PUTTIWAT" userId="a8adac1e-848f-4d84-b961-6a7ffb648b49" providerId="ADAL" clId="{2F9C920F-B837-426B-B15A-4F4274BFBB22}" dt="2023-05-23T11:10:41.526" v="7710" actId="478"/>
-          <ac:cxnSpMkLst>
-            <pc:docMk/>
-            <pc:sldMk cId="416478540" sldId="276"/>
-            <ac:cxnSpMk id="26" creationId="{12EF6CE6-CC78-94B4-A7CB-A4B2AD25238C}"/>
-          </ac:cxnSpMkLst>
-        </pc:cxnChg>
-        <pc:cxnChg chg="mod">
-          <ac:chgData name="KONGKAEW, PUTTIWAT" userId="a8adac1e-848f-4d84-b961-6a7ffb648b49" providerId="ADAL" clId="{2F9C920F-B837-426B-B15A-4F4274BFBB22}" dt="2023-05-23T11:10:45.843" v="7711" actId="14100"/>
-          <ac:cxnSpMkLst>
-            <pc:docMk/>
-            <pc:sldMk cId="416478540" sldId="276"/>
-            <ac:cxnSpMk id="37" creationId="{434B670B-A4E9-FE66-2B14-DD4440328F24}"/>
-          </ac:cxnSpMkLst>
-        </pc:cxnChg>
       </pc:sldChg>
     </pc:docChg>
   </pc:docChgLst>
@@ -3171,7 +2323,7 @@
           <a:p>
             <a:fld id="{EEFE6ADD-7819-4EDC-8188-DF64732BE63F}" type="datetimeFigureOut">
               <a:rPr lang="en-GB" smtClean="0"/>
-              <a:t>23/05/2023</a:t>
+              <a:t>2025-08-26</a:t>
             </a:fld>
             <a:endParaRPr lang="en-GB"/>
           </a:p>
@@ -3509,7 +2661,7 @@
           <a:p>
             <a:fld id="{EEFE6ADD-7819-4EDC-8188-DF64732BE63F}" type="datetimeFigureOut">
               <a:rPr lang="en-GB" smtClean="0"/>
-              <a:t>23/05/2023</a:t>
+              <a:t>2025-08-26</a:t>
             </a:fld>
             <a:endParaRPr lang="en-GB"/>
           </a:p>
@@ -3915,7 +3067,7 @@
           <a:p>
             <a:fld id="{EEFE6ADD-7819-4EDC-8188-DF64732BE63F}" type="datetimeFigureOut">
               <a:rPr lang="en-GB" smtClean="0"/>
-              <a:t>23/05/2023</a:t>
+              <a:t>2025-08-26</a:t>
             </a:fld>
             <a:endParaRPr lang="en-GB"/>
           </a:p>
@@ -4187,7 +3339,7 @@
           <a:p>
             <a:fld id="{EEFE6ADD-7819-4EDC-8188-DF64732BE63F}" type="datetimeFigureOut">
               <a:rPr lang="en-GB" smtClean="0"/>
-              <a:t>23/05/2023</a:t>
+              <a:t>2025-08-26</a:t>
             </a:fld>
             <a:endParaRPr lang="en-GB"/>
           </a:p>
@@ -4468,7 +3620,7 @@
           <a:p>
             <a:fld id="{EEFE6ADD-7819-4EDC-8188-DF64732BE63F}" type="datetimeFigureOut">
               <a:rPr lang="en-GB" smtClean="0"/>
-              <a:t>23/05/2023</a:t>
+              <a:t>2025-08-26</a:t>
             </a:fld>
             <a:endParaRPr lang="en-GB"/>
           </a:p>
@@ -5385,13 +4537,15 @@
               </a:ext>
             </a:extLst>
           </p:cNvPr>
-          <p:cNvCxnSpPr/>
+          <p:cNvCxnSpPr>
+            <a:cxnSpLocks/>
+          </p:cNvCxnSpPr>
           <p:nvPr/>
         </p:nvCxnSpPr>
         <p:spPr>
           <a:xfrm flipH="1">
-            <a:off x="7102136" y="754602"/>
-            <a:ext cx="319596" cy="1367161"/>
+            <a:off x="7334250" y="754602"/>
+            <a:ext cx="87482" cy="416973"/>
           </a:xfrm>
           <a:prstGeom prst="straightConnector1">
             <a:avLst/>
@@ -5459,13 +4613,15 @@
               </a:ext>
             </a:extLst>
           </p:cNvPr>
-          <p:cNvCxnSpPr/>
+          <p:cNvCxnSpPr>
+            <a:cxnSpLocks/>
+          </p:cNvCxnSpPr>
           <p:nvPr/>
         </p:nvCxnSpPr>
         <p:spPr>
           <a:xfrm>
             <a:off x="11026066" y="846139"/>
-            <a:ext cx="150920" cy="1346645"/>
+            <a:ext cx="118184" cy="611186"/>
           </a:xfrm>
           <a:prstGeom prst="straightConnector1">
             <a:avLst/>
@@ -5579,6 +4735,271 @@
           </a:p>
         </p:txBody>
       </p:sp>
+      <p:sp>
+        <p:nvSpPr>
+          <p:cNvPr id="13" name="TextBox 12">
+            <a:extLst>
+              <a:ext uri="{FF2B5EF4-FFF2-40B4-BE49-F238E27FC236}">
+                <a16:creationId xmlns:a16="http://schemas.microsoft.com/office/drawing/2014/main" id="{0E8B5480-DE92-0771-AA8B-6BF98A2A862D}"/>
+              </a:ext>
+            </a:extLst>
+          </p:cNvPr>
+          <p:cNvSpPr txBox="1"/>
+          <p:nvPr/>
+        </p:nvSpPr>
+        <p:spPr>
+          <a:xfrm rot="16200000">
+            <a:off x="5481637" y="3348037"/>
+            <a:ext cx="1571625" cy="514350"/>
+          </a:xfrm>
+          <a:prstGeom prst="rect">
+            <a:avLst/>
+          </a:prstGeom>
+          <a:solidFill>
+            <a:schemeClr val="bg1"/>
+          </a:solidFill>
+        </p:spPr>
+        <p:txBody>
+          <a:bodyPr wrap="square" rtlCol="0">
+            <a:spAutoFit/>
+          </a:bodyPr>
+          <a:lstStyle/>
+          <a:p>
+            <a:endParaRPr lang="en-GB" dirty="0"/>
+          </a:p>
+        </p:txBody>
+      </p:sp>
+      <p:grpSp>
+        <p:nvGrpSpPr>
+          <p:cNvPr id="17" name="Group 16">
+            <a:extLst>
+              <a:ext uri="{FF2B5EF4-FFF2-40B4-BE49-F238E27FC236}">
+                <a16:creationId xmlns:a16="http://schemas.microsoft.com/office/drawing/2014/main" id="{EEFB6A19-7C80-54F0-E98F-470AD9F31098}"/>
+              </a:ext>
+            </a:extLst>
+          </p:cNvPr>
+          <p:cNvGrpSpPr/>
+          <p:nvPr/>
+        </p:nvGrpSpPr>
+        <p:grpSpPr>
+          <a:xfrm>
+            <a:off x="6219429" y="1857375"/>
+            <a:ext cx="4959572" cy="2248279"/>
+            <a:chOff x="6219429" y="1857375"/>
+            <a:chExt cx="4959572" cy="2248279"/>
+          </a:xfrm>
+        </p:grpSpPr>
+        <p:sp>
+          <p:nvSpPr>
+            <p:cNvPr id="3" name="TextBox 2">
+              <a:extLst>
+                <a:ext uri="{FF2B5EF4-FFF2-40B4-BE49-F238E27FC236}">
+                  <a16:creationId xmlns:a16="http://schemas.microsoft.com/office/drawing/2014/main" id="{EF516597-E7C5-9821-7DA5-E9ACEEFBD80B}"/>
+                </a:ext>
+              </a:extLst>
+            </p:cNvPr>
+            <p:cNvSpPr txBox="1"/>
+            <p:nvPr/>
+          </p:nvSpPr>
+          <p:spPr>
+            <a:xfrm>
+              <a:off x="7572375" y="1857375"/>
+              <a:ext cx="3219450" cy="369332"/>
+            </a:xfrm>
+            <a:prstGeom prst="rect">
+              <a:avLst/>
+            </a:prstGeom>
+            <a:solidFill>
+              <a:schemeClr val="bg1"/>
+            </a:solidFill>
+          </p:spPr>
+          <p:txBody>
+            <a:bodyPr wrap="square" rtlCol="0">
+              <a:spAutoFit/>
+            </a:bodyPr>
+            <a:lstStyle/>
+            <a:p>
+              <a:endParaRPr lang="en-GB" dirty="0"/>
+            </a:p>
+          </p:txBody>
+        </p:sp>
+        <p:sp>
+          <p:nvSpPr>
+            <p:cNvPr id="4" name="TextBox 3">
+              <a:extLst>
+                <a:ext uri="{FF2B5EF4-FFF2-40B4-BE49-F238E27FC236}">
+                  <a16:creationId xmlns:a16="http://schemas.microsoft.com/office/drawing/2014/main" id="{19E2AEDD-2081-284A-D213-07D2E1AC2EC1}"/>
+                </a:ext>
+              </a:extLst>
+            </p:cNvPr>
+            <p:cNvSpPr txBox="1"/>
+            <p:nvPr/>
+          </p:nvSpPr>
+          <p:spPr>
+            <a:xfrm>
+              <a:off x="10448925" y="2362200"/>
+              <a:ext cx="723900" cy="514350"/>
+            </a:xfrm>
+            <a:prstGeom prst="rect">
+              <a:avLst/>
+            </a:prstGeom>
+            <a:solidFill>
+              <a:schemeClr val="bg1"/>
+            </a:solidFill>
+          </p:spPr>
+          <p:txBody>
+            <a:bodyPr wrap="square" rtlCol="0">
+              <a:spAutoFit/>
+            </a:bodyPr>
+            <a:lstStyle/>
+            <a:p>
+              <a:endParaRPr lang="en-GB" dirty="0"/>
+            </a:p>
+          </p:txBody>
+        </p:sp>
+        <p:sp>
+          <p:nvSpPr>
+            <p:cNvPr id="5" name="TextBox 4">
+              <a:extLst>
+                <a:ext uri="{FF2B5EF4-FFF2-40B4-BE49-F238E27FC236}">
+                  <a16:creationId xmlns:a16="http://schemas.microsoft.com/office/drawing/2014/main" id="{C70E6F2C-B582-2222-A0FC-E1CB131E8AC4}"/>
+                </a:ext>
+              </a:extLst>
+            </p:cNvPr>
+            <p:cNvSpPr txBox="1"/>
+            <p:nvPr/>
+          </p:nvSpPr>
+          <p:spPr>
+            <a:xfrm>
+              <a:off x="10372725" y="2286000"/>
+              <a:ext cx="546945" cy="276999"/>
+            </a:xfrm>
+            <a:prstGeom prst="rect">
+              <a:avLst/>
+            </a:prstGeom>
+            <a:noFill/>
+          </p:spPr>
+          <p:txBody>
+            <a:bodyPr wrap="none" rtlCol="0">
+              <a:spAutoFit/>
+            </a:bodyPr>
+            <a:lstStyle/>
+            <a:p>
+              <a:r>
+                <a:rPr lang="en-GB" sz="1200" dirty="0"/>
+                <a:t>Mean</a:t>
+              </a:r>
+              <a:endParaRPr lang="en-GB" sz="2000" dirty="0"/>
+            </a:p>
+          </p:txBody>
+        </p:sp>
+        <p:sp>
+          <p:nvSpPr>
+            <p:cNvPr id="6" name="TextBox 5">
+              <a:extLst>
+                <a:ext uri="{FF2B5EF4-FFF2-40B4-BE49-F238E27FC236}">
+                  <a16:creationId xmlns:a16="http://schemas.microsoft.com/office/drawing/2014/main" id="{AA096EC2-9AB0-71E8-D6B0-0040112B1067}"/>
+                </a:ext>
+              </a:extLst>
+            </p:cNvPr>
+            <p:cNvSpPr txBox="1"/>
+            <p:nvPr/>
+          </p:nvSpPr>
+          <p:spPr>
+            <a:xfrm>
+              <a:off x="10372725" y="2486025"/>
+              <a:ext cx="384914" cy="276999"/>
+            </a:xfrm>
+            <a:prstGeom prst="rect">
+              <a:avLst/>
+            </a:prstGeom>
+            <a:noFill/>
+          </p:spPr>
+          <p:txBody>
+            <a:bodyPr wrap="none" rtlCol="0">
+              <a:spAutoFit/>
+            </a:bodyPr>
+            <a:lstStyle/>
+            <a:p>
+              <a:r>
+                <a:rPr lang="en-GB" sz="1200" dirty="0"/>
+                <a:t>Std</a:t>
+              </a:r>
+              <a:endParaRPr lang="en-GB" sz="2000" dirty="0"/>
+            </a:p>
+          </p:txBody>
+        </p:sp>
+        <p:sp>
+          <p:nvSpPr>
+            <p:cNvPr id="7" name="TextBox 6">
+              <a:extLst>
+                <a:ext uri="{FF2B5EF4-FFF2-40B4-BE49-F238E27FC236}">
+                  <a16:creationId xmlns:a16="http://schemas.microsoft.com/office/drawing/2014/main" id="{94E3EAF0-D998-475B-110D-F125C1BADF40}"/>
+                </a:ext>
+              </a:extLst>
+            </p:cNvPr>
+            <p:cNvSpPr txBox="1"/>
+            <p:nvPr/>
+          </p:nvSpPr>
+          <p:spPr>
+            <a:xfrm>
+              <a:off x="10363200" y="2667000"/>
+              <a:ext cx="815801" cy="276999"/>
+            </a:xfrm>
+            <a:prstGeom prst="rect">
+              <a:avLst/>
+            </a:prstGeom>
+            <a:noFill/>
+          </p:spPr>
+          <p:txBody>
+            <a:bodyPr wrap="none" rtlCol="0">
+              <a:spAutoFit/>
+            </a:bodyPr>
+            <a:lstStyle/>
+            <a:p>
+              <a:r>
+                <a:rPr lang="en-GB" sz="1200" dirty="0"/>
+                <a:t>Measured</a:t>
+              </a:r>
+            </a:p>
+          </p:txBody>
+        </p:sp>
+        <p:sp>
+          <p:nvSpPr>
+            <p:cNvPr id="10" name="TextBox 9">
+              <a:extLst>
+                <a:ext uri="{FF2B5EF4-FFF2-40B4-BE49-F238E27FC236}">
+                  <a16:creationId xmlns:a16="http://schemas.microsoft.com/office/drawing/2014/main" id="{C925412C-FE44-66DD-28E7-2DC14DFB38C4}"/>
+                </a:ext>
+              </a:extLst>
+            </p:cNvPr>
+            <p:cNvSpPr txBox="1"/>
+            <p:nvPr/>
+          </p:nvSpPr>
+          <p:spPr>
+            <a:xfrm rot="16200000">
+              <a:off x="5800725" y="3409950"/>
+              <a:ext cx="1114408" cy="276999"/>
+            </a:xfrm>
+            <a:prstGeom prst="rect">
+              <a:avLst/>
+            </a:prstGeom>
+            <a:noFill/>
+          </p:spPr>
+          <p:txBody>
+            <a:bodyPr wrap="none" rtlCol="0">
+              <a:spAutoFit/>
+            </a:bodyPr>
+            <a:lstStyle/>
+            <a:p>
+              <a:r>
+                <a:rPr lang="en-GB" sz="1200" dirty="0"/>
+                <a:t>RMS OPD (nm)</a:t>
+              </a:r>
+            </a:p>
+          </p:txBody>
+        </p:sp>
+      </p:grpSp>
     </p:spTree>
     <p:extLst>
       <p:ext uri="{BB962C8B-B14F-4D97-AF65-F5344CB8AC3E}">
@@ -7446,6 +6867,254 @@
       </p:grpSpPr>
       <p:pic>
         <p:nvPicPr>
+          <p:cNvPr id="4" name="Content Placeholder 6" descr="A picture containing text, screenshot, line, plot&#10;&#10;Description automatically generated">
+            <a:extLst>
+              <a:ext uri="{FF2B5EF4-FFF2-40B4-BE49-F238E27FC236}">
+                <a16:creationId xmlns:a16="http://schemas.microsoft.com/office/drawing/2014/main" id="{D12C46A5-852F-3FB9-DD37-C91E8CC621E0}"/>
+              </a:ext>
+            </a:extLst>
+          </p:cNvPr>
+          <p:cNvPicPr>
+            <a:picLocks noGrp="1" noChangeAspect="1"/>
+          </p:cNvPicPr>
+          <p:nvPr>
+            <p:ph idx="1"/>
+          </p:nvPr>
+        </p:nvPicPr>
+        <p:blipFill>
+          <a:blip r:embed="rId2">
+            <a:extLst>
+              <a:ext uri="{28A0092B-C50C-407E-A947-70E740481C1C}">
+                <a14:useLocalDpi xmlns:a14="http://schemas.microsoft.com/office/drawing/2010/main" val="0"/>
+              </a:ext>
+            </a:extLst>
+          </a:blip>
+          <a:stretch>
+            <a:fillRect/>
+          </a:stretch>
+        </p:blipFill>
+        <p:spPr>
+          <a:xfrm>
+            <a:off x="3762273" y="2028824"/>
+            <a:ext cx="3719654" cy="2543517"/>
+          </a:xfrm>
+        </p:spPr>
+      </p:pic>
+      <p:sp>
+        <p:nvSpPr>
+          <p:cNvPr id="5" name="TextBox 4">
+            <a:extLst>
+              <a:ext uri="{FF2B5EF4-FFF2-40B4-BE49-F238E27FC236}">
+                <a16:creationId xmlns:a16="http://schemas.microsoft.com/office/drawing/2014/main" id="{BBEB1D0B-2DD5-16F4-1FEC-BB46F82B1B3A}"/>
+              </a:ext>
+            </a:extLst>
+          </p:cNvPr>
+          <p:cNvSpPr txBox="1"/>
+          <p:nvPr/>
+        </p:nvSpPr>
+        <p:spPr>
+          <a:xfrm>
+            <a:off x="5124444" y="4348163"/>
+            <a:ext cx="1381125" cy="215444"/>
+          </a:xfrm>
+          <a:prstGeom prst="rect">
+            <a:avLst/>
+          </a:prstGeom>
+          <a:solidFill>
+            <a:schemeClr val="bg1"/>
+          </a:solidFill>
+        </p:spPr>
+        <p:txBody>
+          <a:bodyPr wrap="square" rtlCol="0">
+            <a:spAutoFit/>
+          </a:bodyPr>
+          <a:lstStyle/>
+          <a:p>
+            <a:pPr algn="ctr"/>
+            <a:r>
+              <a:rPr lang="en-GB" sz="800" dirty="0"/>
+              <a:t>Wind speed (m/s)</a:t>
+            </a:r>
+          </a:p>
+        </p:txBody>
+      </p:sp>
+      <p:sp>
+        <p:nvSpPr>
+          <p:cNvPr id="6" name="TextBox 5">
+            <a:extLst>
+              <a:ext uri="{FF2B5EF4-FFF2-40B4-BE49-F238E27FC236}">
+                <a16:creationId xmlns:a16="http://schemas.microsoft.com/office/drawing/2014/main" id="{269569BB-09EE-3538-0074-FD71C30031B3}"/>
+              </a:ext>
+            </a:extLst>
+          </p:cNvPr>
+          <p:cNvSpPr txBox="1"/>
+          <p:nvPr/>
+        </p:nvSpPr>
+        <p:spPr>
+          <a:xfrm rot="16200000">
+            <a:off x="3133720" y="3024196"/>
+            <a:ext cx="1381125" cy="215444"/>
+          </a:xfrm>
+          <a:prstGeom prst="rect">
+            <a:avLst/>
+          </a:prstGeom>
+          <a:solidFill>
+            <a:schemeClr val="bg1"/>
+          </a:solidFill>
+        </p:spPr>
+        <p:txBody>
+          <a:bodyPr wrap="square" rtlCol="0">
+            <a:spAutoFit/>
+          </a:bodyPr>
+          <a:lstStyle/>
+          <a:p>
+            <a:pPr algn="ctr"/>
+            <a:r>
+              <a:rPr lang="en-GB" sz="800" dirty="0"/>
+              <a:t>RMS OPD (nm)</a:t>
+            </a:r>
+          </a:p>
+        </p:txBody>
+      </p:sp>
+      <p:sp>
+        <p:nvSpPr>
+          <p:cNvPr id="7" name="TextBox 6">
+            <a:extLst>
+              <a:ext uri="{FF2B5EF4-FFF2-40B4-BE49-F238E27FC236}">
+                <a16:creationId xmlns:a16="http://schemas.microsoft.com/office/drawing/2014/main" id="{86216EA6-BC94-13DA-558F-58524D67AB3B}"/>
+              </a:ext>
+            </a:extLst>
+          </p:cNvPr>
+          <p:cNvSpPr txBox="1"/>
+          <p:nvPr/>
+        </p:nvSpPr>
+        <p:spPr>
+          <a:xfrm>
+            <a:off x="4548182" y="2176463"/>
+            <a:ext cx="981081" cy="246221"/>
+          </a:xfrm>
+          <a:prstGeom prst="rect">
+            <a:avLst/>
+          </a:prstGeom>
+          <a:solidFill>
+            <a:schemeClr val="bg1"/>
+          </a:solidFill>
+        </p:spPr>
+        <p:txBody>
+          <a:bodyPr wrap="square" rtlCol="0">
+            <a:spAutoFit/>
+          </a:bodyPr>
+          <a:lstStyle/>
+          <a:p>
+            <a:pPr algn="ctr"/>
+            <a:endParaRPr lang="en-GB" sz="1000" dirty="0"/>
+          </a:p>
+        </p:txBody>
+      </p:sp>
+      <p:sp>
+        <p:nvSpPr>
+          <p:cNvPr id="8" name="TextBox 7">
+            <a:extLst>
+              <a:ext uri="{FF2B5EF4-FFF2-40B4-BE49-F238E27FC236}">
+                <a16:creationId xmlns:a16="http://schemas.microsoft.com/office/drawing/2014/main" id="{05632D6A-FD24-F1DA-FC77-414A936DC3C8}"/>
+              </a:ext>
+            </a:extLst>
+          </p:cNvPr>
+          <p:cNvSpPr txBox="1"/>
+          <p:nvPr/>
+        </p:nvSpPr>
+        <p:spPr>
+          <a:xfrm>
+            <a:off x="4448170" y="2114550"/>
+            <a:ext cx="604844" cy="215444"/>
+          </a:xfrm>
+          <a:prstGeom prst="rect">
+            <a:avLst/>
+          </a:prstGeom>
+          <a:noFill/>
+        </p:spPr>
+        <p:txBody>
+          <a:bodyPr wrap="square" rtlCol="0">
+            <a:spAutoFit/>
+          </a:bodyPr>
+          <a:lstStyle/>
+          <a:p>
+            <a:pPr algn="ctr"/>
+            <a:r>
+              <a:rPr lang="en-GB" sz="800" dirty="0"/>
+              <a:t>Expected</a:t>
+            </a:r>
+          </a:p>
+        </p:txBody>
+      </p:sp>
+      <p:sp>
+        <p:nvSpPr>
+          <p:cNvPr id="9" name="TextBox 8">
+            <a:extLst>
+              <a:ext uri="{FF2B5EF4-FFF2-40B4-BE49-F238E27FC236}">
+                <a16:creationId xmlns:a16="http://schemas.microsoft.com/office/drawing/2014/main" id="{0C441AF2-8A36-8CF1-EA6D-870B4DAF435B}"/>
+              </a:ext>
+            </a:extLst>
+          </p:cNvPr>
+          <p:cNvSpPr txBox="1"/>
+          <p:nvPr/>
+        </p:nvSpPr>
+        <p:spPr>
+          <a:xfrm>
+            <a:off x="4462458" y="2257425"/>
+            <a:ext cx="604844" cy="215444"/>
+          </a:xfrm>
+          <a:prstGeom prst="rect">
+            <a:avLst/>
+          </a:prstGeom>
+          <a:noFill/>
+        </p:spPr>
+        <p:txBody>
+          <a:bodyPr wrap="square" rtlCol="0">
+            <a:spAutoFit/>
+          </a:bodyPr>
+          <a:lstStyle/>
+          <a:p>
+            <a:pPr algn="ctr"/>
+            <a:r>
+              <a:rPr lang="en-GB" sz="800" dirty="0"/>
+              <a:t>Measured</a:t>
+            </a:r>
+          </a:p>
+        </p:txBody>
+      </p:sp>
+    </p:spTree>
+    <p:extLst>
+      <p:ext uri="{BB962C8B-B14F-4D97-AF65-F5344CB8AC3E}">
+        <p14:creationId xmlns:p14="http://schemas.microsoft.com/office/powerpoint/2010/main" val="3810459738"/>
+      </p:ext>
+    </p:extLst>
+  </p:cSld>
+  <p:clrMapOvr>
+    <a:masterClrMapping/>
+  </p:clrMapOvr>
+</p:sld>
+</file>
+
+<file path=ppt/slides/slide18.xml><?xml version="1.0" encoding="utf-8"?>
+<p:sld xmlns:a="http://schemas.openxmlformats.org/drawingml/2006/main" xmlns:r="http://schemas.openxmlformats.org/officeDocument/2006/relationships" xmlns:p="http://schemas.openxmlformats.org/presentationml/2006/main">
+  <p:cSld>
+    <p:spTree>
+      <p:nvGrpSpPr>
+        <p:cNvPr id="1" name=""/>
+        <p:cNvGrpSpPr/>
+        <p:nvPr/>
+      </p:nvGrpSpPr>
+      <p:grpSpPr>
+        <a:xfrm>
+          <a:off x="0" y="0"/>
+          <a:ext cx="0" cy="0"/>
+          <a:chOff x="0" y="0"/>
+          <a:chExt cx="0" cy="0"/>
+        </a:xfrm>
+      </p:grpSpPr>
+      <p:pic>
+        <p:nvPicPr>
           <p:cNvPr id="8" name="Content Placeholder 7" descr="A picture containing text, screenshot, line, diagram&#10;&#10;Description automatically generated">
             <a:extLst>
               <a:ext uri="{FF2B5EF4-FFF2-40B4-BE49-F238E27FC236}">
@@ -8016,7 +7685,7 @@
 </p:sld>
 </file>
 
-<file path=ppt/slides/slide18.xml><?xml version="1.0" encoding="utf-8"?>
+<file path=ppt/slides/slide19.xml><?xml version="1.0" encoding="utf-8"?>
 <p:sld xmlns:a="http://schemas.openxmlformats.org/drawingml/2006/main" xmlns:r="http://schemas.openxmlformats.org/officeDocument/2006/relationships" xmlns:p="http://schemas.openxmlformats.org/presentationml/2006/main" show="0">
   <p:cSld>
     <p:spTree>
@@ -8705,180 +8374,6 @@
 </p:sld>
 </file>
 
-<file path=ppt/slides/slide19.xml><?xml version="1.0" encoding="utf-8"?>
-<p:sld xmlns:a="http://schemas.openxmlformats.org/drawingml/2006/main" xmlns:r="http://schemas.openxmlformats.org/officeDocument/2006/relationships" xmlns:p="http://schemas.openxmlformats.org/presentationml/2006/main">
-  <p:cSld>
-    <p:spTree>
-      <p:nvGrpSpPr>
-        <p:cNvPr id="1" name=""/>
-        <p:cNvGrpSpPr/>
-        <p:nvPr/>
-      </p:nvGrpSpPr>
-      <p:grpSpPr>
-        <a:xfrm>
-          <a:off x="0" y="0"/>
-          <a:ext cx="0" cy="0"/>
-          <a:chOff x="0" y="0"/>
-          <a:chExt cx="0" cy="0"/>
-        </a:xfrm>
-      </p:grpSpPr>
-      <p:sp>
-        <p:nvSpPr>
-          <p:cNvPr id="2" name="Title 1">
-            <a:extLst>
-              <a:ext uri="{FF2B5EF4-FFF2-40B4-BE49-F238E27FC236}">
-                <a16:creationId xmlns:a16="http://schemas.microsoft.com/office/drawing/2014/main" id="{1D2FE50F-59E2-F91B-860F-D486549D775B}"/>
-              </a:ext>
-            </a:extLst>
-          </p:cNvPr>
-          <p:cNvSpPr>
-            <a:spLocks noGrp="1"/>
-          </p:cNvSpPr>
-          <p:nvPr>
-            <p:ph type="title"/>
-          </p:nvPr>
-        </p:nvSpPr>
-        <p:spPr/>
-        <p:txBody>
-          <a:bodyPr/>
-          <a:lstStyle/>
-          <a:p>
-            <a:r>
-              <a:rPr lang="en-GB" dirty="0"/>
-              <a:t>Other sources of error?</a:t>
-            </a:r>
-          </a:p>
-        </p:txBody>
-      </p:sp>
-      <p:sp>
-        <p:nvSpPr>
-          <p:cNvPr id="3" name="Content Placeholder 2">
-            <a:extLst>
-              <a:ext uri="{FF2B5EF4-FFF2-40B4-BE49-F238E27FC236}">
-                <a16:creationId xmlns:a16="http://schemas.microsoft.com/office/drawing/2014/main" id="{0C88BBD9-4318-C664-79B4-5DC4019C0B90}"/>
-              </a:ext>
-            </a:extLst>
-          </p:cNvPr>
-          <p:cNvSpPr>
-            <a:spLocks noGrp="1"/>
-          </p:cNvSpPr>
-          <p:nvPr>
-            <p:ph idx="1"/>
-          </p:nvPr>
-        </p:nvSpPr>
-        <p:spPr/>
-        <p:txBody>
-          <a:bodyPr>
-            <a:normAutofit fontScale="85000" lnSpcReduction="20000"/>
-          </a:bodyPr>
-          <a:lstStyle/>
-          <a:p>
-            <a:r>
-              <a:rPr lang="en-GB" dirty="0"/>
-              <a:t>Have not test SOAPY’s SHWFS error</a:t>
-            </a:r>
-          </a:p>
-          <a:p>
-            <a:r>
-              <a:rPr lang="en-GB" dirty="0"/>
-              <a:t>slopes temporal PSD</a:t>
-            </a:r>
-          </a:p>
-          <a:p>
-            <a:r>
-              <a:rPr lang="en-GB" dirty="0"/>
-              <a:t>Effect of varying </a:t>
-            </a:r>
-            <a:r>
-              <a:rPr lang="en-GB" dirty="0" err="1"/>
-              <a:t>svd</a:t>
-            </a:r>
-            <a:r>
-              <a:rPr lang="en-GB" dirty="0"/>
-              <a:t> on Strehl ratio</a:t>
-            </a:r>
-          </a:p>
-          <a:p>
-            <a:endParaRPr lang="en-GB" dirty="0"/>
-          </a:p>
-          <a:p>
-            <a:r>
-              <a:rPr lang="en-GB" dirty="0"/>
-              <a:t>Grab and </a:t>
-            </a:r>
-            <a:r>
-              <a:rPr lang="en-GB" dirty="0" err="1"/>
-              <a:t>analyze</a:t>
-            </a:r>
-            <a:r>
-              <a:rPr lang="en-GB" dirty="0"/>
-              <a:t> slopes</a:t>
-            </a:r>
-          </a:p>
-          <a:p>
-            <a:pPr lvl="1"/>
-            <a:r>
-              <a:rPr lang="en-GB" dirty="0"/>
-              <a:t>Tip/tilt vs time series </a:t>
-            </a:r>
-            <a:r>
-              <a:rPr lang="en-GB" dirty="0">
-                <a:sym typeface="Wingdings" panose="05000000000000000000" pitchFamily="2" charset="2"/>
-              </a:rPr>
-              <a:t> </a:t>
-            </a:r>
-            <a:r>
-              <a:rPr lang="en-GB" dirty="0"/>
-              <a:t>PSD(tip/tilt vs time) </a:t>
-            </a:r>
-            <a:r>
-              <a:rPr lang="en-GB" dirty="0">
-                <a:sym typeface="Wingdings" panose="05000000000000000000" pitchFamily="2" charset="2"/>
-              </a:rPr>
-              <a:t> tip/tilt frequencies</a:t>
-            </a:r>
-          </a:p>
-          <a:p>
-            <a:pPr lvl="1"/>
-            <a:r>
-              <a:rPr lang="en-GB" dirty="0"/>
-              <a:t>Slope covariance ?</a:t>
-            </a:r>
-          </a:p>
-          <a:p>
-            <a:pPr lvl="1"/>
-            <a:r>
-              <a:rPr lang="en-GB" dirty="0"/>
-              <a:t>TIM B &amp; RICHARD WILSON SLODAR papers</a:t>
-            </a:r>
-          </a:p>
-          <a:p>
-            <a:pPr lvl="1"/>
-            <a:r>
-              <a:rPr lang="en-GB" dirty="0"/>
-              <a:t>Time series of 30s for half meter </a:t>
-            </a:r>
-            <a:r>
-              <a:rPr lang="en-GB" dirty="0" err="1"/>
-              <a:t>subap</a:t>
-            </a:r>
-            <a:endParaRPr lang="en-GB" dirty="0"/>
-          </a:p>
-        </p:txBody>
-      </p:sp>
-    </p:spTree>
-    <p:extLst>
-      <p:ext uri="{BB962C8B-B14F-4D97-AF65-F5344CB8AC3E}">
-        <p14:creationId xmlns:p14="http://schemas.microsoft.com/office/powerpoint/2010/main" val="3517991577"/>
-      </p:ext>
-    </p:extLst>
-  </p:cSld>
-  <p:clrMapOvr>
-    <a:masterClrMapping/>
-  </p:clrMapOvr>
-</p:sld>
-</file>
-
 <file path=ppt/slides/slide2.xml><?xml version="1.0" encoding="utf-8"?>
 <p:sld xmlns:a="http://schemas.openxmlformats.org/drawingml/2006/main" xmlns:r="http://schemas.openxmlformats.org/officeDocument/2006/relationships" xmlns:p="http://schemas.openxmlformats.org/presentationml/2006/main">
   <p:cSld>
@@ -8982,6 +8477,180 @@
     <p:extLst>
       <p:ext uri="{BB962C8B-B14F-4D97-AF65-F5344CB8AC3E}">
         <p14:creationId xmlns:p14="http://schemas.microsoft.com/office/powerpoint/2010/main" val="941823532"/>
+      </p:ext>
+    </p:extLst>
+  </p:cSld>
+  <p:clrMapOvr>
+    <a:masterClrMapping/>
+  </p:clrMapOvr>
+</p:sld>
+</file>
+
+<file path=ppt/slides/slide20.xml><?xml version="1.0" encoding="utf-8"?>
+<p:sld xmlns:a="http://schemas.openxmlformats.org/drawingml/2006/main" xmlns:r="http://schemas.openxmlformats.org/officeDocument/2006/relationships" xmlns:p="http://schemas.openxmlformats.org/presentationml/2006/main">
+  <p:cSld>
+    <p:spTree>
+      <p:nvGrpSpPr>
+        <p:cNvPr id="1" name=""/>
+        <p:cNvGrpSpPr/>
+        <p:nvPr/>
+      </p:nvGrpSpPr>
+      <p:grpSpPr>
+        <a:xfrm>
+          <a:off x="0" y="0"/>
+          <a:ext cx="0" cy="0"/>
+          <a:chOff x="0" y="0"/>
+          <a:chExt cx="0" cy="0"/>
+        </a:xfrm>
+      </p:grpSpPr>
+      <p:sp>
+        <p:nvSpPr>
+          <p:cNvPr id="2" name="Title 1">
+            <a:extLst>
+              <a:ext uri="{FF2B5EF4-FFF2-40B4-BE49-F238E27FC236}">
+                <a16:creationId xmlns:a16="http://schemas.microsoft.com/office/drawing/2014/main" id="{1D2FE50F-59E2-F91B-860F-D486549D775B}"/>
+              </a:ext>
+            </a:extLst>
+          </p:cNvPr>
+          <p:cNvSpPr>
+            <a:spLocks noGrp="1"/>
+          </p:cNvSpPr>
+          <p:nvPr>
+            <p:ph type="title"/>
+          </p:nvPr>
+        </p:nvSpPr>
+        <p:spPr/>
+        <p:txBody>
+          <a:bodyPr/>
+          <a:lstStyle/>
+          <a:p>
+            <a:r>
+              <a:rPr lang="en-GB" dirty="0"/>
+              <a:t>Other sources of error?</a:t>
+            </a:r>
+          </a:p>
+        </p:txBody>
+      </p:sp>
+      <p:sp>
+        <p:nvSpPr>
+          <p:cNvPr id="3" name="Content Placeholder 2">
+            <a:extLst>
+              <a:ext uri="{FF2B5EF4-FFF2-40B4-BE49-F238E27FC236}">
+                <a16:creationId xmlns:a16="http://schemas.microsoft.com/office/drawing/2014/main" id="{0C88BBD9-4318-C664-79B4-5DC4019C0B90}"/>
+              </a:ext>
+            </a:extLst>
+          </p:cNvPr>
+          <p:cNvSpPr>
+            <a:spLocks noGrp="1"/>
+          </p:cNvSpPr>
+          <p:nvPr>
+            <p:ph idx="1"/>
+          </p:nvPr>
+        </p:nvSpPr>
+        <p:spPr/>
+        <p:txBody>
+          <a:bodyPr>
+            <a:normAutofit fontScale="85000" lnSpcReduction="20000"/>
+          </a:bodyPr>
+          <a:lstStyle/>
+          <a:p>
+            <a:r>
+              <a:rPr lang="en-GB" dirty="0"/>
+              <a:t>Have not test SOAPY’s SHWFS error</a:t>
+            </a:r>
+          </a:p>
+          <a:p>
+            <a:r>
+              <a:rPr lang="en-GB" dirty="0"/>
+              <a:t>slopes temporal PSD</a:t>
+            </a:r>
+          </a:p>
+          <a:p>
+            <a:r>
+              <a:rPr lang="en-GB" dirty="0"/>
+              <a:t>Effect of varying </a:t>
+            </a:r>
+            <a:r>
+              <a:rPr lang="en-GB" dirty="0" err="1"/>
+              <a:t>svd</a:t>
+            </a:r>
+            <a:r>
+              <a:rPr lang="en-GB" dirty="0"/>
+              <a:t> on Strehl ratio</a:t>
+            </a:r>
+          </a:p>
+          <a:p>
+            <a:endParaRPr lang="en-GB" dirty="0"/>
+          </a:p>
+          <a:p>
+            <a:r>
+              <a:rPr lang="en-GB" dirty="0"/>
+              <a:t>Grab and </a:t>
+            </a:r>
+            <a:r>
+              <a:rPr lang="en-GB" dirty="0" err="1"/>
+              <a:t>analyze</a:t>
+            </a:r>
+            <a:r>
+              <a:rPr lang="en-GB" dirty="0"/>
+              <a:t> slopes</a:t>
+            </a:r>
+          </a:p>
+          <a:p>
+            <a:pPr lvl="1"/>
+            <a:r>
+              <a:rPr lang="en-GB" dirty="0"/>
+              <a:t>Tip/tilt vs time series </a:t>
+            </a:r>
+            <a:r>
+              <a:rPr lang="en-GB" dirty="0">
+                <a:sym typeface="Wingdings" panose="05000000000000000000" pitchFamily="2" charset="2"/>
+              </a:rPr>
+              <a:t> </a:t>
+            </a:r>
+            <a:r>
+              <a:rPr lang="en-GB" dirty="0"/>
+              <a:t>PSD(tip/tilt vs time) </a:t>
+            </a:r>
+            <a:r>
+              <a:rPr lang="en-GB" dirty="0">
+                <a:sym typeface="Wingdings" panose="05000000000000000000" pitchFamily="2" charset="2"/>
+              </a:rPr>
+              <a:t> tip/tilt frequencies</a:t>
+            </a:r>
+          </a:p>
+          <a:p>
+            <a:pPr lvl="1"/>
+            <a:r>
+              <a:rPr lang="en-GB" dirty="0"/>
+              <a:t>Slope covariance ?</a:t>
+            </a:r>
+          </a:p>
+          <a:p>
+            <a:pPr lvl="1"/>
+            <a:r>
+              <a:rPr lang="en-GB" dirty="0"/>
+              <a:t>TIM B &amp; RICHARD WILSON SLODAR papers</a:t>
+            </a:r>
+          </a:p>
+          <a:p>
+            <a:pPr lvl="1"/>
+            <a:r>
+              <a:rPr lang="en-GB" dirty="0"/>
+              <a:t>Time series of 30s for half meter </a:t>
+            </a:r>
+            <a:r>
+              <a:rPr lang="en-GB" dirty="0" err="1"/>
+              <a:t>subap</a:t>
+            </a:r>
+            <a:endParaRPr lang="en-GB" dirty="0"/>
+          </a:p>
+        </p:txBody>
+      </p:sp>
+    </p:spTree>
+    <p:extLst>
+      <p:ext uri="{BB962C8B-B14F-4D97-AF65-F5344CB8AC3E}">
+        <p14:creationId xmlns:p14="http://schemas.microsoft.com/office/powerpoint/2010/main" val="3517991577"/>
       </p:ext>
     </p:extLst>
   </p:cSld>

</xml_diff>